<commit_message>
feat: exam-readiness hardening — full site, quiz engine, speaker notes, traceability
- Web showcase: radiation + prioritization learn pages, 2 new interactive
  demos (radiation-demo, priority-demo), usage guide, quiz page, coverage
  matrix, glossary terms (19 new), nav wired (32 sections, 0 broken links)
- Quiz engine: build_bank.py generates 3,170 questions from 260 facts →
  quiz_bank.json; quiz.js provides practice, timed exam, flashcard, review
- Presentations: 2 new slides (Radiation Hardening, Data Prioritization)
  in web deck (29 slides total); speaker notes added to PPTX + PDF;
  roadmap slide marks phases 5-7 as outside exam scope with roadblocks
- Traceability: DELIVERABLES_COVERAGE.md + in-site #coverage page mapping
  all 8 objectives, 4 presentation sections, 7 interview areas to code,
  slides, web sections, and quiz questions
- README.md rewritten (357 lines) reflecting current project state
- All 189 tests passing
</commit_message>
<xml_diff>
--- a/presentation/output/AETHERIX_Presentation.pptx
+++ b/presentation/output/AETHERIX_Presentation.pptx
@@ -131,6 +131,2246 @@
     </a:lvl9pPr>
   </p:defaultTextStyle>
 </p:presentation>
+</file>
+
+<file path=ppt/notesMasters/notesMaster1.xml><?xml version="1.0" encoding="utf-8"?>
+<p:notesMaster xmlns:a="http://schemas.openxmlformats.org/drawingml/2006/main" xmlns:p="http://schemas.openxmlformats.org/presentationml/2006/main" xmlns:r="http://schemas.openxmlformats.org/officeDocument/2006/relationships">
+  <p:cSld>
+    <p:bg>
+      <p:bgRef idx="1001">
+        <a:schemeClr val="bg1"/>
+      </p:bgRef>
+    </p:bg>
+    <p:spTree>
+      <p:nvGrpSpPr>
+        <p:cNvPr id="1" name=""/>
+        <p:cNvGrpSpPr/>
+        <p:nvPr/>
+      </p:nvGrpSpPr>
+      <p:grpSpPr>
+        <a:xfrm>
+          <a:off x="0" y="0"/>
+          <a:ext cx="0" cy="0"/>
+          <a:chOff x="0" y="0"/>
+          <a:chExt cx="0" cy="0"/>
+        </a:xfrm>
+      </p:grpSpPr>
+      <p:sp>
+        <p:nvSpPr>
+          <p:cNvPr id="2" name="Header Placeholder 1"/>
+          <p:cNvSpPr>
+            <a:spLocks noGrp="1"/>
+          </p:cNvSpPr>
+          <p:nvPr>
+            <p:ph type="hdr" sz="quarter"/>
+          </p:nvPr>
+        </p:nvSpPr>
+        <p:spPr>
+          <a:xfrm>
+            <a:off x="0" y="0"/>
+            <a:ext cx="2971800" cy="457200"/>
+          </a:xfrm>
+          <a:prstGeom prst="rect">
+            <a:avLst/>
+          </a:prstGeom>
+        </p:spPr>
+        <p:txBody>
+          <a:bodyPr vert="horz" lIns="91440" tIns="45720" rIns="91440" bIns="45720" rtlCol="0"/>
+          <a:lstStyle>
+            <a:lvl1pPr algn="l">
+              <a:defRPr sz="1200"/>
+            </a:lvl1pPr>
+          </a:lstStyle>
+          <a:p>
+            <a:endParaRPr lang="en-US"/>
+          </a:p>
+        </p:txBody>
+      </p:sp>
+      <p:sp>
+        <p:nvSpPr>
+          <p:cNvPr id="3" name="Date Placeholder 2"/>
+          <p:cNvSpPr>
+            <a:spLocks noGrp="1"/>
+          </p:cNvSpPr>
+          <p:nvPr>
+            <p:ph type="dt" idx="1"/>
+          </p:nvPr>
+        </p:nvSpPr>
+        <p:spPr>
+          <a:xfrm>
+            <a:off x="3884613" y="0"/>
+            <a:ext cx="2971800" cy="457200"/>
+          </a:xfrm>
+          <a:prstGeom prst="rect">
+            <a:avLst/>
+          </a:prstGeom>
+        </p:spPr>
+        <p:txBody>
+          <a:bodyPr vert="horz" lIns="91440" tIns="45720" rIns="91440" bIns="45720" rtlCol="0"/>
+          <a:lstStyle>
+            <a:lvl1pPr algn="r">
+              <a:defRPr sz="1200"/>
+            </a:lvl1pPr>
+          </a:lstStyle>
+          <a:p>
+            <a:fld id="{0F89C1C7-3DCD-1040-A9CF-14679D8B5DDD}" type="datetimeFigureOut">
+              <a:rPr lang="en-US" smtClean="0"/>
+              <a:t>10/17/16</a:t>
+            </a:fld>
+            <a:endParaRPr lang="en-US"/>
+          </a:p>
+        </p:txBody>
+      </p:sp>
+      <p:sp>
+        <p:nvSpPr>
+          <p:cNvPr id="4" name="Slide Image Placeholder 3"/>
+          <p:cNvSpPr>
+            <a:spLocks noGrp="1" noRot="1" noChangeAspect="1"/>
+          </p:cNvSpPr>
+          <p:nvPr>
+            <p:ph type="sldImg" idx="2"/>
+          </p:nvPr>
+        </p:nvSpPr>
+        <p:spPr>
+          <a:xfrm>
+            <a:off x="1143000" y="685800"/>
+            <a:ext cx="4572000" cy="3429000"/>
+          </a:xfrm>
+          <a:prstGeom prst="rect">
+            <a:avLst/>
+          </a:prstGeom>
+          <a:noFill/>
+          <a:ln w="12700">
+            <a:solidFill>
+              <a:prstClr val="black"/>
+            </a:solidFill>
+          </a:ln>
+        </p:spPr>
+        <p:txBody>
+          <a:bodyPr vert="horz" lIns="91440" tIns="45720" rIns="91440" bIns="45720" rtlCol="0" anchor="ctr"/>
+          <a:lstStyle/>
+          <a:p>
+            <a:endParaRPr lang="en-US"/>
+          </a:p>
+        </p:txBody>
+      </p:sp>
+      <p:sp>
+        <p:nvSpPr>
+          <p:cNvPr id="5" name="Notes Placeholder 4"/>
+          <p:cNvSpPr>
+            <a:spLocks noGrp="1"/>
+          </p:cNvSpPr>
+          <p:nvPr>
+            <p:ph type="body" sz="quarter" idx="3"/>
+          </p:nvPr>
+        </p:nvSpPr>
+        <p:spPr>
+          <a:xfrm>
+            <a:off x="685800" y="4343400"/>
+            <a:ext cx="5486400" cy="4114800"/>
+          </a:xfrm>
+          <a:prstGeom prst="rect">
+            <a:avLst/>
+          </a:prstGeom>
+        </p:spPr>
+        <p:txBody>
+          <a:bodyPr vert="horz" lIns="91440" tIns="45720" rIns="91440" bIns="45720" rtlCol="0"/>
+          <a:lstStyle/>
+          <a:p>
+            <a:pPr lvl="0"/>
+            <a:r>
+              <a:rPr lang="en-US" smtClean="0"/>
+              <a:t>Click to edit Master text styles</a:t>
+            </a:r>
+          </a:p>
+          <a:p>
+            <a:pPr lvl="1"/>
+            <a:r>
+              <a:rPr lang="en-US" smtClean="0"/>
+              <a:t>Second level</a:t>
+            </a:r>
+          </a:p>
+          <a:p>
+            <a:pPr lvl="2"/>
+            <a:r>
+              <a:rPr lang="en-US" smtClean="0"/>
+              <a:t>Third level</a:t>
+            </a:r>
+          </a:p>
+          <a:p>
+            <a:pPr lvl="3"/>
+            <a:r>
+              <a:rPr lang="en-US" smtClean="0"/>
+              <a:t>Fourth level</a:t>
+            </a:r>
+          </a:p>
+          <a:p>
+            <a:pPr lvl="4"/>
+            <a:r>
+              <a:rPr lang="en-US" smtClean="0"/>
+              <a:t>Fifth level</a:t>
+            </a:r>
+            <a:endParaRPr lang="en-US"/>
+          </a:p>
+        </p:txBody>
+      </p:sp>
+      <p:sp>
+        <p:nvSpPr>
+          <p:cNvPr id="6" name="Footer Placeholder 5"/>
+          <p:cNvSpPr>
+            <a:spLocks noGrp="1"/>
+          </p:cNvSpPr>
+          <p:nvPr>
+            <p:ph type="ftr" sz="quarter" idx="4"/>
+          </p:nvPr>
+        </p:nvSpPr>
+        <p:spPr>
+          <a:xfrm>
+            <a:off x="0" y="8685213"/>
+            <a:ext cx="2971800" cy="457200"/>
+          </a:xfrm>
+          <a:prstGeom prst="rect">
+            <a:avLst/>
+          </a:prstGeom>
+        </p:spPr>
+        <p:txBody>
+          <a:bodyPr vert="horz" lIns="91440" tIns="45720" rIns="91440" bIns="45720" rtlCol="0" anchor="b"/>
+          <a:lstStyle>
+            <a:lvl1pPr algn="l">
+              <a:defRPr sz="1200"/>
+            </a:lvl1pPr>
+          </a:lstStyle>
+          <a:p>
+            <a:endParaRPr lang="en-US"/>
+          </a:p>
+        </p:txBody>
+      </p:sp>
+      <p:sp>
+        <p:nvSpPr>
+          <p:cNvPr id="7" name="Slide Number Placeholder 6"/>
+          <p:cNvSpPr>
+            <a:spLocks noGrp="1"/>
+          </p:cNvSpPr>
+          <p:nvPr>
+            <p:ph type="sldNum" sz="quarter" idx="5"/>
+          </p:nvPr>
+        </p:nvSpPr>
+        <p:spPr>
+          <a:xfrm>
+            <a:off x="3884613" y="8685213"/>
+            <a:ext cx="2971800" cy="457200"/>
+          </a:xfrm>
+          <a:prstGeom prst="rect">
+            <a:avLst/>
+          </a:prstGeom>
+        </p:spPr>
+        <p:txBody>
+          <a:bodyPr vert="horz" lIns="91440" tIns="45720" rIns="91440" bIns="45720" rtlCol="0" anchor="b"/>
+          <a:lstStyle>
+            <a:lvl1pPr algn="r">
+              <a:defRPr sz="1200"/>
+            </a:lvl1pPr>
+          </a:lstStyle>
+          <a:p>
+            <a:fld id="{BB5E49A5-4136-284D-997B-48E1D791AD67}" type="slidenum">
+              <a:rPr lang="en-US" smtClean="0"/>
+              <a:t>‹#›</a:t>
+            </a:fld>
+            <a:endParaRPr lang="en-US"/>
+          </a:p>
+        </p:txBody>
+      </p:sp>
+    </p:spTree>
+    <p:extLst>
+      <p:ext uri="{BB962C8B-B14F-4D97-AF65-F5344CB8AC3E}">
+        <p14:creationId xmlns:p14="http://schemas.microsoft.com/office/powerpoint/2010/main" val="2623252185"/>
+      </p:ext>
+    </p:extLst>
+  </p:cSld>
+  <p:clrMap bg1="lt1" tx1="dk1" bg2="lt2" tx2="dk2" accent1="accent1" accent2="accent2" accent3="accent3" accent4="accent4" accent5="accent5" accent6="accent6" hlink="hlink" folHlink="folHlink"/>
+  <p:notesStyle>
+    <a:lvl1pPr marL="0" algn="l" defTabSz="457200" rtl="0" eaLnBrk="1" latinLnBrk="0" hangingPunct="1">
+      <a:defRPr sz="1200" kern="1200">
+        <a:solidFill>
+          <a:schemeClr val="tx1"/>
+        </a:solidFill>
+        <a:latin typeface="+mn-lt"/>
+        <a:ea typeface="+mn-ea"/>
+        <a:cs typeface="+mn-cs"/>
+      </a:defRPr>
+    </a:lvl1pPr>
+    <a:lvl2pPr marL="457200" algn="l" defTabSz="457200" rtl="0" eaLnBrk="1" latinLnBrk="0" hangingPunct="1">
+      <a:defRPr sz="1200" kern="1200">
+        <a:solidFill>
+          <a:schemeClr val="tx1"/>
+        </a:solidFill>
+        <a:latin typeface="+mn-lt"/>
+        <a:ea typeface="+mn-ea"/>
+        <a:cs typeface="+mn-cs"/>
+      </a:defRPr>
+    </a:lvl2pPr>
+    <a:lvl3pPr marL="914400" algn="l" defTabSz="457200" rtl="0" eaLnBrk="1" latinLnBrk="0" hangingPunct="1">
+      <a:defRPr sz="1200" kern="1200">
+        <a:solidFill>
+          <a:schemeClr val="tx1"/>
+        </a:solidFill>
+        <a:latin typeface="+mn-lt"/>
+        <a:ea typeface="+mn-ea"/>
+        <a:cs typeface="+mn-cs"/>
+      </a:defRPr>
+    </a:lvl3pPr>
+    <a:lvl4pPr marL="1371600" algn="l" defTabSz="457200" rtl="0" eaLnBrk="1" latinLnBrk="0" hangingPunct="1">
+      <a:defRPr sz="1200" kern="1200">
+        <a:solidFill>
+          <a:schemeClr val="tx1"/>
+        </a:solidFill>
+        <a:latin typeface="+mn-lt"/>
+        <a:ea typeface="+mn-ea"/>
+        <a:cs typeface="+mn-cs"/>
+      </a:defRPr>
+    </a:lvl4pPr>
+    <a:lvl5pPr marL="1828800" algn="l" defTabSz="457200" rtl="0" eaLnBrk="1" latinLnBrk="0" hangingPunct="1">
+      <a:defRPr sz="1200" kern="1200">
+        <a:solidFill>
+          <a:schemeClr val="tx1"/>
+        </a:solidFill>
+        <a:latin typeface="+mn-lt"/>
+        <a:ea typeface="+mn-ea"/>
+        <a:cs typeface="+mn-cs"/>
+      </a:defRPr>
+    </a:lvl5pPr>
+    <a:lvl6pPr marL="2286000" algn="l" defTabSz="457200" rtl="0" eaLnBrk="1" latinLnBrk="0" hangingPunct="1">
+      <a:defRPr sz="1200" kern="1200">
+        <a:solidFill>
+          <a:schemeClr val="tx1"/>
+        </a:solidFill>
+        <a:latin typeface="+mn-lt"/>
+        <a:ea typeface="+mn-ea"/>
+        <a:cs typeface="+mn-cs"/>
+      </a:defRPr>
+    </a:lvl6pPr>
+    <a:lvl7pPr marL="2743200" algn="l" defTabSz="457200" rtl="0" eaLnBrk="1" latinLnBrk="0" hangingPunct="1">
+      <a:defRPr sz="1200" kern="1200">
+        <a:solidFill>
+          <a:schemeClr val="tx1"/>
+        </a:solidFill>
+        <a:latin typeface="+mn-lt"/>
+        <a:ea typeface="+mn-ea"/>
+        <a:cs typeface="+mn-cs"/>
+      </a:defRPr>
+    </a:lvl7pPr>
+    <a:lvl8pPr marL="3200400" algn="l" defTabSz="457200" rtl="0" eaLnBrk="1" latinLnBrk="0" hangingPunct="1">
+      <a:defRPr sz="1200" kern="1200">
+        <a:solidFill>
+          <a:schemeClr val="tx1"/>
+        </a:solidFill>
+        <a:latin typeface="+mn-lt"/>
+        <a:ea typeface="+mn-ea"/>
+        <a:cs typeface="+mn-cs"/>
+      </a:defRPr>
+    </a:lvl8pPr>
+    <a:lvl9pPr marL="3657600" algn="l" defTabSz="457200" rtl="0" eaLnBrk="1" latinLnBrk="0" hangingPunct="1">
+      <a:defRPr sz="1200" kern="1200">
+        <a:solidFill>
+          <a:schemeClr val="tx1"/>
+        </a:solidFill>
+        <a:latin typeface="+mn-lt"/>
+        <a:ea typeface="+mn-ea"/>
+        <a:cs typeface="+mn-cs"/>
+      </a:defRPr>
+    </a:lvl9pPr>
+  </p:notesStyle>
+</p:notesMaster>
+</file>
+
+<file path=ppt/notesSlides/notesSlide1.xml><?xml version="1.0" encoding="utf-8"?>
+<p:notes xmlns:a="http://schemas.openxmlformats.org/drawingml/2006/main" xmlns:p="http://schemas.openxmlformats.org/presentationml/2006/main" xmlns:r="http://schemas.openxmlformats.org/officeDocument/2006/relationships">
+  <p:cSld>
+    <p:spTree>
+      <p:nvGrpSpPr>
+        <p:cNvPr id="1" name=""/>
+        <p:cNvGrpSpPr/>
+        <p:nvPr/>
+      </p:nvGrpSpPr>
+      <p:grpSpPr>
+        <a:xfrm>
+          <a:off x="0" y="0"/>
+          <a:ext cx="0" cy="0"/>
+          <a:chOff x="0" y="0"/>
+          <a:chExt cx="0" cy="0"/>
+        </a:xfrm>
+      </p:grpSpPr>
+      <p:sp>
+        <p:nvSpPr>
+          <p:cNvPr id="2" name="Slide Image Placeholder 1"/>
+          <p:cNvSpPr>
+            <a:spLocks noGrp="1"/>
+          </p:cNvSpPr>
+          <p:nvPr>
+            <p:ph type="sldImg" idx="2"/>
+          </p:nvPr>
+        </p:nvSpPr>
+        <p:spPr/>
+      </p:sp>
+      <p:sp>
+        <p:nvSpPr>
+          <p:cNvPr id="3" name="Notes Placeholder 2"/>
+          <p:cNvSpPr>
+            <a:spLocks noGrp="1"/>
+          </p:cNvSpPr>
+          <p:nvPr>
+            <p:ph type="body" idx="3" sz="quarter"/>
+          </p:nvPr>
+        </p:nvSpPr>
+        <p:spPr/>
+        <p:txBody>
+          <a:bodyPr/>
+          <a:lstStyle/>
+          <a:p>
+            <a:r>
+              <a:t>State your name clearly. Read the topic number and title exactly as on the exam paper. Pause to let examiners see it. Point to the logo. This is your first impression. (30 seconds)</a:t>
+            </a:r>
+          </a:p>
+        </p:txBody>
+      </p:sp>
+      <p:sp>
+        <p:nvSpPr>
+          <p:cNvPr id="4" name="Slide Number Placeholder 3"/>
+          <p:cNvSpPr>
+            <a:spLocks noGrp="1"/>
+          </p:cNvSpPr>
+          <p:nvPr>
+            <p:ph type="sldNum" idx="5" sz="quarter"/>
+          </p:nvPr>
+        </p:nvSpPr>
+        <p:spPr/>
+      </p:sp>
+    </p:spTree>
+  </p:cSld>
+  <p:clrMapOvr>
+    <a:masterClrMapping/>
+  </p:clrMapOvr>
+</p:notes>
+</file>
+
+<file path=ppt/notesSlides/notesSlide10.xml><?xml version="1.0" encoding="utf-8"?>
+<p:notes xmlns:a="http://schemas.openxmlformats.org/drawingml/2006/main" xmlns:p="http://schemas.openxmlformats.org/presentationml/2006/main" xmlns:r="http://schemas.openxmlformats.org/officeDocument/2006/relationships">
+  <p:cSld>
+    <p:spTree>
+      <p:nvGrpSpPr>
+        <p:cNvPr id="1" name=""/>
+        <p:cNvGrpSpPr/>
+        <p:nvPr/>
+      </p:nvGrpSpPr>
+      <p:grpSpPr>
+        <a:xfrm>
+          <a:off x="0" y="0"/>
+          <a:ext cx="0" cy="0"/>
+          <a:chOff x="0" y="0"/>
+          <a:chExt cx="0" cy="0"/>
+        </a:xfrm>
+      </p:grpSpPr>
+      <p:sp>
+        <p:nvSpPr>
+          <p:cNvPr id="2" name="Slide Image Placeholder 1"/>
+          <p:cNvSpPr>
+            <a:spLocks noGrp="1"/>
+          </p:cNvSpPr>
+          <p:nvPr>
+            <p:ph type="sldImg" idx="2"/>
+          </p:nvPr>
+        </p:nvSpPr>
+        <p:spPr/>
+      </p:sp>
+      <p:sp>
+        <p:nvSpPr>
+          <p:cNvPr id="3" name="Notes Placeholder 2"/>
+          <p:cNvSpPr>
+            <a:spLocks noGrp="1"/>
+          </p:cNvSpPr>
+          <p:nvPr>
+            <p:ph type="body" idx="3" sz="quarter"/>
+          </p:nvPr>
+        </p:nvSpPr>
+        <p:spPr/>
+        <p:txBody>
+          <a:bodyPr/>
+          <a:lstStyle/>
+          <a:p>
+            <a:r>
+              <a:t>241 nodes across 5 tiers. Walk through each tier. Earth Ground is the DSN - three stations around the globe for 24/7 coverage. Earth Orbital has LEO laser mesh for optical backhaul. Deep Space has Lagrange point relays - these are the critical innovation for conjunction coverage. Mars Orbital has areostationary relays at 17,032 km. Mars Surface is the most populated tier. (2 minutes)</a:t>
+            </a:r>
+          </a:p>
+        </p:txBody>
+      </p:sp>
+      <p:sp>
+        <p:nvSpPr>
+          <p:cNvPr id="4" name="Slide Number Placeholder 3"/>
+          <p:cNvSpPr>
+            <a:spLocks noGrp="1"/>
+          </p:cNvSpPr>
+          <p:nvPr>
+            <p:ph type="sldNum" idx="5" sz="quarter"/>
+          </p:nvPr>
+        </p:nvSpPr>
+        <p:spPr/>
+      </p:sp>
+    </p:spTree>
+  </p:cSld>
+  <p:clrMapOvr>
+    <a:masterClrMapping/>
+  </p:clrMapOvr>
+</p:notes>
+</file>
+
+<file path=ppt/notesSlides/notesSlide11.xml><?xml version="1.0" encoding="utf-8"?>
+<p:notes xmlns:a="http://schemas.openxmlformats.org/drawingml/2006/main" xmlns:p="http://schemas.openxmlformats.org/presentationml/2006/main" xmlns:r="http://schemas.openxmlformats.org/officeDocument/2006/relationships">
+  <p:cSld>
+    <p:spTree>
+      <p:nvGrpSpPr>
+        <p:cNvPr id="1" name=""/>
+        <p:cNvGrpSpPr/>
+        <p:nvPr/>
+      </p:nvGrpSpPr>
+      <p:grpSpPr>
+        <a:xfrm>
+          <a:off x="0" y="0"/>
+          <a:ext cx="0" cy="0"/>
+          <a:chOff x="0" y="0"/>
+          <a:chExt cx="0" cy="0"/>
+        </a:xfrm>
+      </p:grpSpPr>
+      <p:sp>
+        <p:nvSpPr>
+          <p:cNvPr id="2" name="Slide Image Placeholder 1"/>
+          <p:cNvSpPr>
+            <a:spLocks noGrp="1"/>
+          </p:cNvSpPr>
+          <p:nvPr>
+            <p:ph type="sldImg" idx="2"/>
+          </p:nvPr>
+        </p:nvSpPr>
+        <p:spPr/>
+      </p:sp>
+      <p:sp>
+        <p:nvSpPr>
+          <p:cNvPr id="3" name="Notes Placeholder 2"/>
+          <p:cNvSpPr>
+            <a:spLocks noGrp="1"/>
+          </p:cNvSpPr>
+          <p:nvPr>
+            <p:ph type="body" idx="3" sz="quarter"/>
+          </p:nvPr>
+        </p:nvSpPr>
+        <p:spPr/>
+        <p:txBody>
+          <a:bodyPr/>
+          <a:lstStyle/>
+          <a:p>
+            <a:r>
+              <a:t>Visual overview of the 5-tier topology with 3 redundant paths.</a:t>
+            </a:r>
+          </a:p>
+        </p:txBody>
+      </p:sp>
+      <p:sp>
+        <p:nvSpPr>
+          <p:cNvPr id="4" name="Slide Number Placeholder 3"/>
+          <p:cNvSpPr>
+            <a:spLocks noGrp="1"/>
+          </p:cNvSpPr>
+          <p:nvPr>
+            <p:ph type="sldNum" idx="5" sz="quarter"/>
+          </p:nvPr>
+        </p:nvSpPr>
+        <p:spPr/>
+      </p:sp>
+    </p:spTree>
+  </p:cSld>
+  <p:clrMapOvr>
+    <a:masterClrMapping/>
+  </p:clrMapOvr>
+</p:notes>
+</file>
+
+<file path=ppt/notesSlides/notesSlide12.xml><?xml version="1.0" encoding="utf-8"?>
+<p:notes xmlns:a="http://schemas.openxmlformats.org/drawingml/2006/main" xmlns:p="http://schemas.openxmlformats.org/presentationml/2006/main" xmlns:r="http://schemas.openxmlformats.org/officeDocument/2006/relationships">
+  <p:cSld>
+    <p:spTree>
+      <p:nvGrpSpPr>
+        <p:cNvPr id="1" name=""/>
+        <p:cNvGrpSpPr/>
+        <p:nvPr/>
+      </p:nvGrpSpPr>
+      <p:grpSpPr>
+        <a:xfrm>
+          <a:off x="0" y="0"/>
+          <a:ext cx="0" cy="0"/>
+          <a:chOff x="0" y="0"/>
+          <a:chExt cx="0" cy="0"/>
+        </a:xfrm>
+      </p:grpSpPr>
+      <p:sp>
+        <p:nvSpPr>
+          <p:cNvPr id="2" name="Slide Image Placeholder 1"/>
+          <p:cNvSpPr>
+            <a:spLocks noGrp="1"/>
+          </p:cNvSpPr>
+          <p:nvPr>
+            <p:ph type="sldImg" idx="2"/>
+          </p:nvPr>
+        </p:nvSpPr>
+        <p:spPr/>
+      </p:sp>
+      <p:sp>
+        <p:nvSpPr>
+          <p:cNvPr id="3" name="Notes Placeholder 2"/>
+          <p:cNvSpPr>
+            <a:spLocks noGrp="1"/>
+          </p:cNvSpPr>
+          <p:nvPr>
+            <p:ph type="body" idx="3" sz="quarter"/>
+          </p:nvPr>
+        </p:nvSpPr>
+        <p:spPr/>
+        <p:txBody>
+          <a:bodyPr/>
+          <a:lstStyle/>
+          <a:p>
+            <a:r>
+              <a:t>Network topology visualization.</a:t>
+            </a:r>
+          </a:p>
+        </p:txBody>
+      </p:sp>
+      <p:sp>
+        <p:nvSpPr>
+          <p:cNvPr id="4" name="Slide Number Placeholder 3"/>
+          <p:cNvSpPr>
+            <a:spLocks noGrp="1"/>
+          </p:cNvSpPr>
+          <p:nvPr>
+            <p:ph type="sldNum" idx="5" sz="quarter"/>
+          </p:nvPr>
+        </p:nvSpPr>
+        <p:spPr/>
+      </p:sp>
+    </p:spTree>
+  </p:cSld>
+  <p:clrMapOvr>
+    <a:masterClrMapping/>
+  </p:clrMapOvr>
+</p:notes>
+</file>
+
+<file path=ppt/notesSlides/notesSlide13.xml><?xml version="1.0" encoding="utf-8"?>
+<p:notes xmlns:a="http://schemas.openxmlformats.org/drawingml/2006/main" xmlns:p="http://schemas.openxmlformats.org/presentationml/2006/main" xmlns:r="http://schemas.openxmlformats.org/officeDocument/2006/relationships">
+  <p:cSld>
+    <p:spTree>
+      <p:nvGrpSpPr>
+        <p:cNvPr id="1" name=""/>
+        <p:cNvGrpSpPr/>
+        <p:nvPr/>
+      </p:nvGrpSpPr>
+      <p:grpSpPr>
+        <a:xfrm>
+          <a:off x="0" y="0"/>
+          <a:ext cx="0" cy="0"/>
+          <a:chOff x="0" y="0"/>
+          <a:chExt cx="0" cy="0"/>
+        </a:xfrm>
+      </p:grpSpPr>
+      <p:sp>
+        <p:nvSpPr>
+          <p:cNvPr id="2" name="Slide Image Placeholder 1"/>
+          <p:cNvSpPr>
+            <a:spLocks noGrp="1"/>
+          </p:cNvSpPr>
+          <p:nvPr>
+            <p:ph type="sldImg" idx="2"/>
+          </p:nvPr>
+        </p:nvSpPr>
+        <p:spPr/>
+      </p:sp>
+      <p:sp>
+        <p:nvSpPr>
+          <p:cNvPr id="3" name="Notes Placeholder 2"/>
+          <p:cNvSpPr>
+            <a:spLocks noGrp="1"/>
+          </p:cNvSpPr>
+          <p:nvPr>
+            <p:ph type="body" idx="3" sz="quarter"/>
+          </p:nvPr>
+        </p:nvSpPr>
+        <p:spPr/>
+        <p:txBody>
+          <a:bodyPr/>
+          <a:lstStyle/>
+          <a:p>
+            <a:r>
+              <a:t>RUN THE LIVE DEMO from the Link Budget page. Show the 3 distance scenarios. 1550nm was chosen for telecom heritage and eye safety. FSPL at average distance is -365 dB. The telescope apertures are realistic for spacecraft. RF backup for reliability. (2 minutes)</a:t>
+            </a:r>
+          </a:p>
+        </p:txBody>
+      </p:sp>
+      <p:sp>
+        <p:nvSpPr>
+          <p:cNvPr id="4" name="Slide Number Placeholder 3"/>
+          <p:cNvSpPr>
+            <a:spLocks noGrp="1"/>
+          </p:cNvSpPr>
+          <p:nvPr>
+            <p:ph type="sldNum" idx="5" sz="quarter"/>
+          </p:nvPr>
+        </p:nvSpPr>
+        <p:spPr/>
+      </p:sp>
+    </p:spTree>
+  </p:cSld>
+  <p:clrMapOvr>
+    <a:masterClrMapping/>
+  </p:clrMapOvr>
+</p:notes>
+</file>
+
+<file path=ppt/notesSlides/notesSlide14.xml><?xml version="1.0" encoding="utf-8"?>
+<p:notes xmlns:a="http://schemas.openxmlformats.org/drawingml/2006/main" xmlns:p="http://schemas.openxmlformats.org/presentationml/2006/main" xmlns:r="http://schemas.openxmlformats.org/officeDocument/2006/relationships">
+  <p:cSld>
+    <p:spTree>
+      <p:nvGrpSpPr>
+        <p:cNvPr id="1" name=""/>
+        <p:cNvGrpSpPr/>
+        <p:nvPr/>
+      </p:nvGrpSpPr>
+      <p:grpSpPr>
+        <a:xfrm>
+          <a:off x="0" y="0"/>
+          <a:ext cx="0" cy="0"/>
+          <a:chOff x="0" y="0"/>
+          <a:chExt cx="0" cy="0"/>
+        </a:xfrm>
+      </p:grpSpPr>
+      <p:sp>
+        <p:nvSpPr>
+          <p:cNvPr id="2" name="Slide Image Placeholder 1"/>
+          <p:cNvSpPr>
+            <a:spLocks noGrp="1"/>
+          </p:cNvSpPr>
+          <p:nvPr>
+            <p:ph type="sldImg" idx="2"/>
+          </p:nvPr>
+        </p:nvSpPr>
+        <p:spPr/>
+      </p:sp>
+      <p:sp>
+        <p:nvSpPr>
+          <p:cNvPr id="3" name="Notes Placeholder 2"/>
+          <p:cNvSpPr>
+            <a:spLocks noGrp="1"/>
+          </p:cNvSpPr>
+          <p:nvPr>
+            <p:ph type="body" idx="3" sz="quarter"/>
+          </p:nvPr>
+        </p:nvSpPr>
+        <p:spPr/>
+        <p:txBody>
+          <a:bodyPr/>
+          <a:lstStyle/>
+          <a:p>
+            <a:r>
+              <a:t>Interactive journey visualization.</a:t>
+            </a:r>
+          </a:p>
+        </p:txBody>
+      </p:sp>
+      <p:sp>
+        <p:nvSpPr>
+          <p:cNvPr id="4" name="Slide Number Placeholder 3"/>
+          <p:cNvSpPr>
+            <a:spLocks noGrp="1"/>
+          </p:cNvSpPr>
+          <p:nvPr>
+            <p:ph type="sldNum" idx="5" sz="quarter"/>
+          </p:nvPr>
+        </p:nvSpPr>
+        <p:spPr/>
+      </p:sp>
+    </p:spTree>
+  </p:cSld>
+  <p:clrMapOvr>
+    <a:masterClrMapping/>
+  </p:clrMapOvr>
+</p:notes>
+</file>
+
+<file path=ppt/notesSlides/notesSlide15.xml><?xml version="1.0" encoding="utf-8"?>
+<p:notes xmlns:a="http://schemas.openxmlformats.org/drawingml/2006/main" xmlns:p="http://schemas.openxmlformats.org/presentationml/2006/main" xmlns:r="http://schemas.openxmlformats.org/officeDocument/2006/relationships">
+  <p:cSld>
+    <p:spTree>
+      <p:nvGrpSpPr>
+        <p:cNvPr id="1" name=""/>
+        <p:cNvGrpSpPr/>
+        <p:nvPr/>
+      </p:nvGrpSpPr>
+      <p:grpSpPr>
+        <a:xfrm>
+          <a:off x="0" y="0"/>
+          <a:ext cx="0" cy="0"/>
+          <a:chOff x="0" y="0"/>
+          <a:chExt cx="0" cy="0"/>
+        </a:xfrm>
+      </p:grpSpPr>
+      <p:sp>
+        <p:nvSpPr>
+          <p:cNvPr id="2" name="Slide Image Placeholder 1"/>
+          <p:cNvSpPr>
+            <a:spLocks noGrp="1"/>
+          </p:cNvSpPr>
+          <p:nvPr>
+            <p:ph type="sldImg" idx="2"/>
+          </p:nvPr>
+        </p:nvSpPr>
+        <p:spPr/>
+      </p:sp>
+      <p:sp>
+        <p:nvSpPr>
+          <p:cNvPr id="3" name="Notes Placeholder 2"/>
+          <p:cNvSpPr>
+            <a:spLocks noGrp="1"/>
+          </p:cNvSpPr>
+          <p:nvPr>
+            <p:ph type="body" idx="3" sz="quarter"/>
+          </p:nvPr>
+        </p:nvSpPr>
+        <p:spPr/>
+        <p:txBody>
+          <a:bodyPr/>
+          <a:lstStyle/>
+          <a:p>
+            <a:r>
+              <a:t>CGR is what NASA uses today. It's static - you have to pre-compute schedules. Our RL agent learns from experience. 8 state variables, 4 actions. The reward function balances delivery probability against delay, hops, drops, and energy. Multi-agent federated learning means agents at each node share knowledge. (2 minutes)</a:t>
+            </a:r>
+          </a:p>
+        </p:txBody>
+      </p:sp>
+      <p:sp>
+        <p:nvSpPr>
+          <p:cNvPr id="4" name="Slide Number Placeholder 3"/>
+          <p:cNvSpPr>
+            <a:spLocks noGrp="1"/>
+          </p:cNvSpPr>
+          <p:nvPr>
+            <p:ph type="sldNum" idx="5" sz="quarter"/>
+          </p:nvPr>
+        </p:nvSpPr>
+        <p:spPr/>
+      </p:sp>
+    </p:spTree>
+  </p:cSld>
+  <p:clrMapOvr>
+    <a:masterClrMapping/>
+  </p:clrMapOvr>
+</p:notes>
+</file>
+
+<file path=ppt/notesSlides/notesSlide16.xml><?xml version="1.0" encoding="utf-8"?>
+<p:notes xmlns:a="http://schemas.openxmlformats.org/drawingml/2006/main" xmlns:p="http://schemas.openxmlformats.org/presentationml/2006/main" xmlns:r="http://schemas.openxmlformats.org/officeDocument/2006/relationships">
+  <p:cSld>
+    <p:spTree>
+      <p:nvGrpSpPr>
+        <p:cNvPr id="1" name=""/>
+        <p:cNvGrpSpPr/>
+        <p:nvPr/>
+      </p:nvGrpSpPr>
+      <p:grpSpPr>
+        <a:xfrm>
+          <a:off x="0" y="0"/>
+          <a:ext cx="0" cy="0"/>
+          <a:chOff x="0" y="0"/>
+          <a:chExt cx="0" cy="0"/>
+        </a:xfrm>
+      </p:grpSpPr>
+      <p:sp>
+        <p:nvSpPr>
+          <p:cNvPr id="2" name="Slide Image Placeholder 1"/>
+          <p:cNvSpPr>
+            <a:spLocks noGrp="1"/>
+          </p:cNvSpPr>
+          <p:nvPr>
+            <p:ph type="sldImg" idx="2"/>
+          </p:nvPr>
+        </p:nvSpPr>
+        <p:spPr/>
+      </p:sp>
+      <p:sp>
+        <p:nvSpPr>
+          <p:cNvPr id="3" name="Notes Placeholder 2"/>
+          <p:cNvSpPr>
+            <a:spLocks noGrp="1"/>
+          </p:cNvSpPr>
+          <p:nvPr>
+            <p:ph type="body" idx="3" sz="quarter"/>
+          </p:nvPr>
+        </p:nvSpPr>
+        <p:spPr/>
+        <p:txBody>
+          <a:bodyPr/>
+          <a:lstStyle/>
+          <a:p>
+            <a:r>
+              <a:t>BB84 is beautifully simple: send qubits, measure, compare bases, check QBER. If QBER is below 11%, no one listened in. CASCADE reconciliation and privacy amplification clean the key. E91 uses entanglement. Quantum repeaters at Lagrange points extend range. Post-quantum crypto as backup layer. (2 minutes)</a:t>
+            </a:r>
+          </a:p>
+        </p:txBody>
+      </p:sp>
+      <p:sp>
+        <p:nvSpPr>
+          <p:cNvPr id="4" name="Slide Number Placeholder 3"/>
+          <p:cNvSpPr>
+            <a:spLocks noGrp="1"/>
+          </p:cNvSpPr>
+          <p:nvPr>
+            <p:ph type="sldNum" idx="5" sz="quarter"/>
+          </p:nvPr>
+        </p:nvSpPr>
+        <p:spPr/>
+      </p:sp>
+    </p:spTree>
+  </p:cSld>
+  <p:clrMapOvr>
+    <a:masterClrMapping/>
+  </p:clrMapOvr>
+</p:notes>
+</file>
+
+<file path=ppt/notesSlides/notesSlide17.xml><?xml version="1.0" encoding="utf-8"?>
+<p:notes xmlns:a="http://schemas.openxmlformats.org/drawingml/2006/main" xmlns:p="http://schemas.openxmlformats.org/presentationml/2006/main" xmlns:r="http://schemas.openxmlformats.org/officeDocument/2006/relationships">
+  <p:cSld>
+    <p:spTree>
+      <p:nvGrpSpPr>
+        <p:cNvPr id="1" name=""/>
+        <p:cNvGrpSpPr/>
+        <p:nvPr/>
+      </p:nvGrpSpPr>
+      <p:grpSpPr>
+        <a:xfrm>
+          <a:off x="0" y="0"/>
+          <a:ext cx="0" cy="0"/>
+          <a:chOff x="0" y="0"/>
+          <a:chExt cx="0" cy="0"/>
+        </a:xfrm>
+      </p:grpSpPr>
+      <p:sp>
+        <p:nvSpPr>
+          <p:cNvPr id="2" name="Slide Image Placeholder 1"/>
+          <p:cNvSpPr>
+            <a:spLocks noGrp="1"/>
+          </p:cNvSpPr>
+          <p:nvPr>
+            <p:ph type="sldImg" idx="2"/>
+          </p:nvPr>
+        </p:nvSpPr>
+        <p:spPr/>
+      </p:sp>
+      <p:sp>
+        <p:nvSpPr>
+          <p:cNvPr id="3" name="Notes Placeholder 2"/>
+          <p:cNvSpPr>
+            <a:spLocks noGrp="1"/>
+          </p:cNvSpPr>
+          <p:nvPr>
+            <p:ph type="body" idx="3" sz="quarter"/>
+          </p:nvPr>
+        </p:nvSpPr>
+        <p:spPr/>
+        <p:txBody>
+          <a:bodyPr/>
+          <a:lstStyle/>
+          <a:p>
+            <a:r>
+              <a:t>Mars and Earth dance around the Sun with a 26-month synodic period. Everything changes - distance, delay, bandwidth. At opposition we get great bandwidth. At conjunction, the Sun blocks everything. Our Lagrange relays at ES-L4 and ES-L5 maintain 50-70% capacity during conjunction. Doppler shift of 15 GHz at optical wavelengths requires real-time compensation. (1.5 minutes)</a:t>
+            </a:r>
+          </a:p>
+        </p:txBody>
+      </p:sp>
+      <p:sp>
+        <p:nvSpPr>
+          <p:cNvPr id="4" name="Slide Number Placeholder 3"/>
+          <p:cNvSpPr>
+            <a:spLocks noGrp="1"/>
+          </p:cNvSpPr>
+          <p:nvPr>
+            <p:ph type="sldNum" idx="5" sz="quarter"/>
+          </p:nvPr>
+        </p:nvSpPr>
+        <p:spPr/>
+      </p:sp>
+    </p:spTree>
+  </p:cSld>
+  <p:clrMapOvr>
+    <a:masterClrMapping/>
+  </p:clrMapOvr>
+</p:notes>
+</file>
+
+<file path=ppt/notesSlides/notesSlide18.xml><?xml version="1.0" encoding="utf-8"?>
+<p:notes xmlns:a="http://schemas.openxmlformats.org/drawingml/2006/main" xmlns:p="http://schemas.openxmlformats.org/presentationml/2006/main" xmlns:r="http://schemas.openxmlformats.org/officeDocument/2006/relationships">
+  <p:cSld>
+    <p:spTree>
+      <p:nvGrpSpPr>
+        <p:cNvPr id="1" name=""/>
+        <p:cNvGrpSpPr/>
+        <p:nvPr/>
+      </p:nvGrpSpPr>
+      <p:grpSpPr>
+        <a:xfrm>
+          <a:off x="0" y="0"/>
+          <a:ext cx="0" cy="0"/>
+          <a:chOff x="0" y="0"/>
+          <a:chExt cx="0" cy="0"/>
+        </a:xfrm>
+      </p:grpSpPr>
+      <p:sp>
+        <p:nvSpPr>
+          <p:cNvPr id="2" name="Slide Image Placeholder 1"/>
+          <p:cNvSpPr>
+            <a:spLocks noGrp="1"/>
+          </p:cNvSpPr>
+          <p:nvPr>
+            <p:ph type="sldImg" idx="2"/>
+          </p:nvPr>
+        </p:nvSpPr>
+        <p:spPr/>
+      </p:sp>
+      <p:sp>
+        <p:nvSpPr>
+          <p:cNvPr id="3" name="Notes Placeholder 2"/>
+          <p:cNvSpPr>
+            <a:spLocks noGrp="1"/>
+          </p:cNvSpPr>
+          <p:nvPr>
+            <p:ph type="body" idx="3" sz="quarter"/>
+          </p:nvPr>
+        </p:nvSpPr>
+        <p:spPr/>
+        <p:txBody>
+          <a:bodyPr/>
+          <a:lstStyle/>
+          <a:p>
+            <a:r>
+              <a:t>Space radiation is relentless. SEUs flip bits constantly - about 37,000 during a Mars transit. Our defense-in-depth: TMR masks logic faults (3,334x reliability gain), SECDED ECC corrects single-bit errors, scrubbing prevents double-bit accumulation, and FDIR with a watchdog catches everything else. The RAD750 can tolerate 200 krad - far above what a Mars mission needs. (1.5 minutes)</a:t>
+            </a:r>
+          </a:p>
+        </p:txBody>
+      </p:sp>
+      <p:sp>
+        <p:nvSpPr>
+          <p:cNvPr id="4" name="Slide Number Placeholder 3"/>
+          <p:cNvSpPr>
+            <a:spLocks noGrp="1"/>
+          </p:cNvSpPr>
+          <p:nvPr>
+            <p:ph type="sldNum" idx="5" sz="quarter"/>
+          </p:nvPr>
+        </p:nvSpPr>
+        <p:spPr/>
+      </p:sp>
+    </p:spTree>
+  </p:cSld>
+  <p:clrMapOvr>
+    <a:masterClrMapping/>
+  </p:clrMapOvr>
+</p:notes>
+</file>
+
+<file path=ppt/notesSlides/notesSlide19.xml><?xml version="1.0" encoding="utf-8"?>
+<p:notes xmlns:a="http://schemas.openxmlformats.org/drawingml/2006/main" xmlns:p="http://schemas.openxmlformats.org/presentationml/2006/main" xmlns:r="http://schemas.openxmlformats.org/officeDocument/2006/relationships">
+  <p:cSld>
+    <p:spTree>
+      <p:nvGrpSpPr>
+        <p:cNvPr id="1" name=""/>
+        <p:cNvGrpSpPr/>
+        <p:nvPr/>
+      </p:nvGrpSpPr>
+      <p:grpSpPr>
+        <a:xfrm>
+          <a:off x="0" y="0"/>
+          <a:ext cx="0" cy="0"/>
+          <a:chOff x="0" y="0"/>
+          <a:chExt cx="0" cy="0"/>
+        </a:xfrm>
+      </p:grpSpPr>
+      <p:sp>
+        <p:nvSpPr>
+          <p:cNvPr id="2" name="Slide Image Placeholder 1"/>
+          <p:cNvSpPr>
+            <a:spLocks noGrp="1"/>
+          </p:cNvSpPr>
+          <p:nvPr>
+            <p:ph type="sldImg" idx="2"/>
+          </p:nvPr>
+        </p:nvSpPr>
+        <p:spPr/>
+      </p:sp>
+      <p:sp>
+        <p:nvSpPr>
+          <p:cNvPr id="3" name="Notes Placeholder 2"/>
+          <p:cNvSpPr>
+            <a:spLocks noGrp="1"/>
+          </p:cNvSpPr>
+          <p:nvPr>
+            <p:ph type="body" idx="3" sz="quarter"/>
+          </p:nvPr>
+        </p:nvSpPr>
+        <p:spPr/>
+        <p:txBody>
+          <a:bodyPr/>
+          <a:lstStyle/>
+          <a:p>
+            <a:r>
+              <a:t>Like an emergency room. P0 emergency gets sent immediately - it can even preempt an in-progress transfer. P1 mission-critical next. P2 routine science. P4 bulk data fills remaining bandwidth. Compression multiplies effective capacity: 3x for telemetry, 10x for images, 50x for video. Our scheduler keeps the link at 100% utilization by fragmenting large bundles. (1.5 minutes)</a:t>
+            </a:r>
+          </a:p>
+        </p:txBody>
+      </p:sp>
+      <p:sp>
+        <p:nvSpPr>
+          <p:cNvPr id="4" name="Slide Number Placeholder 3"/>
+          <p:cNvSpPr>
+            <a:spLocks noGrp="1"/>
+          </p:cNvSpPr>
+          <p:nvPr>
+            <p:ph type="sldNum" idx="5" sz="quarter"/>
+          </p:nvPr>
+        </p:nvSpPr>
+        <p:spPr/>
+      </p:sp>
+    </p:spTree>
+  </p:cSld>
+  <p:clrMapOvr>
+    <a:masterClrMapping/>
+  </p:clrMapOvr>
+</p:notes>
+</file>
+
+<file path=ppt/notesSlides/notesSlide2.xml><?xml version="1.0" encoding="utf-8"?>
+<p:notes xmlns:a="http://schemas.openxmlformats.org/drawingml/2006/main" xmlns:p="http://schemas.openxmlformats.org/presentationml/2006/main" xmlns:r="http://schemas.openxmlformats.org/officeDocument/2006/relationships">
+  <p:cSld>
+    <p:spTree>
+      <p:nvGrpSpPr>
+        <p:cNvPr id="1" name=""/>
+        <p:cNvGrpSpPr/>
+        <p:nvPr/>
+      </p:nvGrpSpPr>
+      <p:grpSpPr>
+        <a:xfrm>
+          <a:off x="0" y="0"/>
+          <a:ext cx="0" cy="0"/>
+          <a:chOff x="0" y="0"/>
+          <a:chExt cx="0" cy="0"/>
+        </a:xfrm>
+      </p:grpSpPr>
+      <p:sp>
+        <p:nvSpPr>
+          <p:cNvPr id="2" name="Slide Image Placeholder 1"/>
+          <p:cNvSpPr>
+            <a:spLocks noGrp="1"/>
+          </p:cNvSpPr>
+          <p:nvPr>
+            <p:ph type="sldImg" idx="2"/>
+          </p:nvPr>
+        </p:nvSpPr>
+        <p:spPr/>
+      </p:sp>
+      <p:sp>
+        <p:nvSpPr>
+          <p:cNvPr id="3" name="Notes Placeholder 2"/>
+          <p:cNvSpPr>
+            <a:spLocks noGrp="1"/>
+          </p:cNvSpPr>
+          <p:nvPr>
+            <p:ph type="body" idx="3" sz="quarter"/>
+          </p:nvPr>
+        </p:nvSpPr>
+        <p:spPr/>
+        <p:txBody>
+          <a:bodyPr/>
+          <a:lstStyle/>
+          <a:p>
+            <a:r>
+              <a:t>Quick overview of what we will cover. 13 topics across 29 slides. About 20 minutes. (20 seconds)</a:t>
+            </a:r>
+          </a:p>
+        </p:txBody>
+      </p:sp>
+      <p:sp>
+        <p:nvSpPr>
+          <p:cNvPr id="4" name="Slide Number Placeholder 3"/>
+          <p:cNvSpPr>
+            <a:spLocks noGrp="1"/>
+          </p:cNvSpPr>
+          <p:nvPr>
+            <p:ph type="sldNum" idx="5" sz="quarter"/>
+          </p:nvPr>
+        </p:nvSpPr>
+        <p:spPr/>
+      </p:sp>
+    </p:spTree>
+  </p:cSld>
+  <p:clrMapOvr>
+    <a:masterClrMapping/>
+  </p:clrMapOvr>
+</p:notes>
+</file>
+
+<file path=ppt/notesSlides/notesSlide20.xml><?xml version="1.0" encoding="utf-8"?>
+<p:notes xmlns:a="http://schemas.openxmlformats.org/drawingml/2006/main" xmlns:p="http://schemas.openxmlformats.org/presentationml/2006/main" xmlns:r="http://schemas.openxmlformats.org/officeDocument/2006/relationships">
+  <p:cSld>
+    <p:spTree>
+      <p:nvGrpSpPr>
+        <p:cNvPr id="1" name=""/>
+        <p:cNvGrpSpPr/>
+        <p:nvPr/>
+      </p:nvGrpSpPr>
+      <p:grpSpPr>
+        <a:xfrm>
+          <a:off x="0" y="0"/>
+          <a:ext cx="0" cy="0"/>
+          <a:chOff x="0" y="0"/>
+          <a:chExt cx="0" cy="0"/>
+        </a:xfrm>
+      </p:grpSpPr>
+      <p:sp>
+        <p:nvSpPr>
+          <p:cNvPr id="2" name="Slide Image Placeholder 1"/>
+          <p:cNvSpPr>
+            <a:spLocks noGrp="1"/>
+          </p:cNvSpPr>
+          <p:nvPr>
+            <p:ph type="sldImg" idx="2"/>
+          </p:nvPr>
+        </p:nvSpPr>
+        <p:spPr/>
+      </p:sp>
+      <p:sp>
+        <p:nvSpPr>
+          <p:cNvPr id="3" name="Notes Placeholder 2"/>
+          <p:cNvSpPr>
+            <a:spLocks noGrp="1"/>
+          </p:cNvSpPr>
+          <p:nvPr>
+            <p:ph type="body" idx="3" sz="quarter"/>
+          </p:nvPr>
+        </p:nvSpPr>
+        <p:spPr/>
+        <p:txBody>
+          <a:bodyPr/>
+          <a:lstStyle/>
+          <a:p>
+            <a:r>
+              <a:t>Walk through the 7-hop journey. 500MB from Perseverance to JPL. Total transit ~13 min vs 12.5 min light-time - near speed of light! DTN overhead under 5%. Key point: if link drops at hop 5, the bundle stays stored at hop 4 and retries. No data loss. RUN LIVE DEMO if time permits. (2 minutes)</a:t>
+            </a:r>
+          </a:p>
+        </p:txBody>
+      </p:sp>
+      <p:sp>
+        <p:nvSpPr>
+          <p:cNvPr id="4" name="Slide Number Placeholder 3"/>
+          <p:cNvSpPr>
+            <a:spLocks noGrp="1"/>
+          </p:cNvSpPr>
+          <p:nvPr>
+            <p:ph type="sldNum" idx="5" sz="quarter"/>
+          </p:nvPr>
+        </p:nvSpPr>
+        <p:spPr/>
+      </p:sp>
+    </p:spTree>
+  </p:cSld>
+  <p:clrMapOvr>
+    <a:masterClrMapping/>
+  </p:clrMapOvr>
+</p:notes>
+</file>
+
+<file path=ppt/notesSlides/notesSlide21.xml><?xml version="1.0" encoding="utf-8"?>
+<p:notes xmlns:a="http://schemas.openxmlformats.org/drawingml/2006/main" xmlns:p="http://schemas.openxmlformats.org/presentationml/2006/main" xmlns:r="http://schemas.openxmlformats.org/officeDocument/2006/relationships">
+  <p:cSld>
+    <p:spTree>
+      <p:nvGrpSpPr>
+        <p:cNvPr id="1" name=""/>
+        <p:cNvGrpSpPr/>
+        <p:nvPr/>
+      </p:nvGrpSpPr>
+      <p:grpSpPr>
+        <a:xfrm>
+          <a:off x="0" y="0"/>
+          <a:ext cx="0" cy="0"/>
+          <a:chOff x="0" y="0"/>
+          <a:chExt cx="0" cy="0"/>
+        </a:xfrm>
+      </p:grpSpPr>
+      <p:sp>
+        <p:nvSpPr>
+          <p:cNvPr id="2" name="Slide Image Placeholder 1"/>
+          <p:cNvSpPr>
+            <a:spLocks noGrp="1"/>
+          </p:cNvSpPr>
+          <p:nvPr>
+            <p:ph type="sldImg" idx="2"/>
+          </p:nvPr>
+        </p:nvSpPr>
+        <p:spPr/>
+      </p:sp>
+      <p:sp>
+        <p:nvSpPr>
+          <p:cNvPr id="3" name="Notes Placeholder 2"/>
+          <p:cNvSpPr>
+            <a:spLocks noGrp="1"/>
+          </p:cNvSpPr>
+          <p:nvPr>
+            <p:ph type="body" idx="3" sz="quarter"/>
+          </p:nvPr>
+        </p:nvSpPr>
+        <p:spPr/>
+        <p:txBody>
+          <a:bodyPr/>
+          <a:lstStyle/>
+          <a:p>
+            <a:r>
+              <a:t>End-to-end bundle journey through all protocol layers.</a:t>
+            </a:r>
+          </a:p>
+        </p:txBody>
+      </p:sp>
+      <p:sp>
+        <p:nvSpPr>
+          <p:cNvPr id="4" name="Slide Number Placeholder 3"/>
+          <p:cNvSpPr>
+            <a:spLocks noGrp="1"/>
+          </p:cNvSpPr>
+          <p:nvPr>
+            <p:ph type="sldNum" idx="5" sz="quarter"/>
+          </p:nvPr>
+        </p:nvSpPr>
+        <p:spPr/>
+      </p:sp>
+    </p:spTree>
+  </p:cSld>
+  <p:clrMapOvr>
+    <a:masterClrMapping/>
+  </p:clrMapOvr>
+</p:notes>
+</file>
+
+<file path=ppt/notesSlides/notesSlide22.xml><?xml version="1.0" encoding="utf-8"?>
+<p:notes xmlns:a="http://schemas.openxmlformats.org/drawingml/2006/main" xmlns:p="http://schemas.openxmlformats.org/presentationml/2006/main" xmlns:r="http://schemas.openxmlformats.org/officeDocument/2006/relationships">
+  <p:cSld>
+    <p:spTree>
+      <p:nvGrpSpPr>
+        <p:cNvPr id="1" name=""/>
+        <p:cNvGrpSpPr/>
+        <p:nvPr/>
+      </p:nvGrpSpPr>
+      <p:grpSpPr>
+        <a:xfrm>
+          <a:off x="0" y="0"/>
+          <a:ext cx="0" cy="0"/>
+          <a:chOff x="0" y="0"/>
+          <a:chExt cx="0" cy="0"/>
+        </a:xfrm>
+      </p:grpSpPr>
+      <p:sp>
+        <p:nvSpPr>
+          <p:cNvPr id="2" name="Slide Image Placeholder 1"/>
+          <p:cNvSpPr>
+            <a:spLocks noGrp="1"/>
+          </p:cNvSpPr>
+          <p:nvPr>
+            <p:ph type="sldImg" idx="2"/>
+          </p:nvPr>
+        </p:nvSpPr>
+        <p:spPr/>
+      </p:sp>
+      <p:sp>
+        <p:nvSpPr>
+          <p:cNvPr id="3" name="Notes Placeholder 2"/>
+          <p:cNvSpPr>
+            <a:spLocks noGrp="1"/>
+          </p:cNvSpPr>
+          <p:nvPr>
+            <p:ph type="body" idx="3" sz="quarter"/>
+          </p:nvPr>
+        </p:nvSpPr>
+        <p:spPr/>
+        <p:txBody>
+          <a:bodyPr/>
+          <a:lstStyle/>
+          <a:p>
+            <a:r>
+              <a:t>Visual data flow through the protocol stack.</a:t>
+            </a:r>
+          </a:p>
+        </p:txBody>
+      </p:sp>
+      <p:sp>
+        <p:nvSpPr>
+          <p:cNvPr id="4" name="Slide Number Placeholder 3"/>
+          <p:cNvSpPr>
+            <a:spLocks noGrp="1"/>
+          </p:cNvSpPr>
+          <p:nvPr>
+            <p:ph type="sldNum" idx="5" sz="quarter"/>
+          </p:nvPr>
+        </p:nvSpPr>
+        <p:spPr/>
+      </p:sp>
+    </p:spTree>
+  </p:cSld>
+  <p:clrMapOvr>
+    <a:masterClrMapping/>
+  </p:clrMapOvr>
+</p:notes>
+</file>
+
+<file path=ppt/notesSlides/notesSlide23.xml><?xml version="1.0" encoding="utf-8"?>
+<p:notes xmlns:a="http://schemas.openxmlformats.org/drawingml/2006/main" xmlns:p="http://schemas.openxmlformats.org/presentationml/2006/main" xmlns:r="http://schemas.openxmlformats.org/officeDocument/2006/relationships">
+  <p:cSld>
+    <p:spTree>
+      <p:nvGrpSpPr>
+        <p:cNvPr id="1" name=""/>
+        <p:cNvGrpSpPr/>
+        <p:nvPr/>
+      </p:nvGrpSpPr>
+      <p:grpSpPr>
+        <a:xfrm>
+          <a:off x="0" y="0"/>
+          <a:ext cx="0" cy="0"/>
+          <a:chOff x="0" y="0"/>
+          <a:chExt cx="0" cy="0"/>
+        </a:xfrm>
+      </p:grpSpPr>
+      <p:sp>
+        <p:nvSpPr>
+          <p:cNvPr id="2" name="Slide Image Placeholder 1"/>
+          <p:cNvSpPr>
+            <a:spLocks noGrp="1"/>
+          </p:cNvSpPr>
+          <p:nvPr>
+            <p:ph type="sldImg" idx="2"/>
+          </p:nvPr>
+        </p:nvSpPr>
+        <p:spPr/>
+      </p:sp>
+      <p:sp>
+        <p:nvSpPr>
+          <p:cNvPr id="3" name="Notes Placeholder 2"/>
+          <p:cNvSpPr>
+            <a:spLocks noGrp="1"/>
+          </p:cNvSpPr>
+          <p:nvPr>
+            <p:ph type="body" idx="3" sz="quarter"/>
+          </p:nvPr>
+        </p:nvSpPr>
+        <p:spPr/>
+        <p:txBody>
+          <a:bodyPr/>
+          <a:lstStyle/>
+          <a:p>
+            <a:r>
+              <a:t>Hit these numbers with confidence. 10-100x faster. &gt;95% availability vs 60-75%. Quantum-secure. 241 nodes vs 5-10 assets. The conjunction improvement is thanks to Lagrange relays. All metrics are backed by our simulation engine. (1 minute)</a:t>
+            </a:r>
+          </a:p>
+        </p:txBody>
+      </p:sp>
+      <p:sp>
+        <p:nvSpPr>
+          <p:cNvPr id="4" name="Slide Number Placeholder 3"/>
+          <p:cNvSpPr>
+            <a:spLocks noGrp="1"/>
+          </p:cNvSpPr>
+          <p:nvPr>
+            <p:ph type="sldNum" idx="5" sz="quarter"/>
+          </p:nvPr>
+        </p:nvSpPr>
+        <p:spPr/>
+      </p:sp>
+    </p:spTree>
+  </p:cSld>
+  <p:clrMapOvr>
+    <a:masterClrMapping/>
+  </p:clrMapOvr>
+</p:notes>
+</file>
+
+<file path=ppt/notesSlides/notesSlide24.xml><?xml version="1.0" encoding="utf-8"?>
+<p:notes xmlns:a="http://schemas.openxmlformats.org/drawingml/2006/main" xmlns:p="http://schemas.openxmlformats.org/presentationml/2006/main" xmlns:r="http://schemas.openxmlformats.org/officeDocument/2006/relationships">
+  <p:cSld>
+    <p:spTree>
+      <p:nvGrpSpPr>
+        <p:cNvPr id="1" name=""/>
+        <p:cNvGrpSpPr/>
+        <p:nvPr/>
+      </p:nvGrpSpPr>
+      <p:grpSpPr>
+        <a:xfrm>
+          <a:off x="0" y="0"/>
+          <a:ext cx="0" cy="0"/>
+          <a:chOff x="0" y="0"/>
+          <a:chExt cx="0" cy="0"/>
+        </a:xfrm>
+      </p:grpSpPr>
+      <p:sp>
+        <p:nvSpPr>
+          <p:cNvPr id="2" name="Slide Image Placeholder 1"/>
+          <p:cNvSpPr>
+            <a:spLocks noGrp="1"/>
+          </p:cNvSpPr>
+          <p:nvPr>
+            <p:ph type="sldImg" idx="2"/>
+          </p:nvPr>
+        </p:nvSpPr>
+        <p:spPr/>
+      </p:sp>
+      <p:sp>
+        <p:nvSpPr>
+          <p:cNvPr id="3" name="Notes Placeholder 2"/>
+          <p:cNvSpPr>
+            <a:spLocks noGrp="1"/>
+          </p:cNvSpPr>
+          <p:nvPr>
+            <p:ph type="body" idx="3" sz="quarter"/>
+          </p:nvPr>
+        </p:nvSpPr>
+        <p:spPr/>
+        <p:txBody>
+          <a:bodyPr/>
+          <a:lstStyle/>
+          <a:p>
+            <a:r>
+              <a:t>This is real, working code. 27 Python modules, 189 tests, 12 interactive demos. All the physics is real - no mocked data. The showcase site has live calculators you can use right now. Standards compliance is complete - CCSDS, IETF, and NIST. (1.5 minutes)</a:t>
+            </a:r>
+          </a:p>
+        </p:txBody>
+      </p:sp>
+      <p:sp>
+        <p:nvSpPr>
+          <p:cNvPr id="4" name="Slide Number Placeholder 3"/>
+          <p:cNvSpPr>
+            <a:spLocks noGrp="1"/>
+          </p:cNvSpPr>
+          <p:nvPr>
+            <p:ph type="sldNum" idx="5" sz="quarter"/>
+          </p:nvPr>
+        </p:nvSpPr>
+        <p:spPr/>
+      </p:sp>
+    </p:spTree>
+  </p:cSld>
+  <p:clrMapOvr>
+    <a:masterClrMapping/>
+  </p:clrMapOvr>
+</p:notes>
+</file>
+
+<file path=ppt/notesSlides/notesSlide25.xml><?xml version="1.0" encoding="utf-8"?>
+<p:notes xmlns:a="http://schemas.openxmlformats.org/drawingml/2006/main" xmlns:p="http://schemas.openxmlformats.org/presentationml/2006/main" xmlns:r="http://schemas.openxmlformats.org/officeDocument/2006/relationships">
+  <p:cSld>
+    <p:spTree>
+      <p:nvGrpSpPr>
+        <p:cNvPr id="1" name=""/>
+        <p:cNvGrpSpPr/>
+        <p:nvPr/>
+      </p:nvGrpSpPr>
+      <p:grpSpPr>
+        <a:xfrm>
+          <a:off x="0" y="0"/>
+          <a:ext cx="0" cy="0"/>
+          <a:chOff x="0" y="0"/>
+          <a:chExt cx="0" cy="0"/>
+        </a:xfrm>
+      </p:grpSpPr>
+      <p:sp>
+        <p:nvSpPr>
+          <p:cNvPr id="2" name="Slide Image Placeholder 1"/>
+          <p:cNvSpPr>
+            <a:spLocks noGrp="1"/>
+          </p:cNvSpPr>
+          <p:nvPr>
+            <p:ph type="sldImg" idx="2"/>
+          </p:nvPr>
+        </p:nvSpPr>
+        <p:spPr/>
+      </p:sp>
+      <p:sp>
+        <p:nvSpPr>
+          <p:cNvPr id="3" name="Notes Placeholder 2"/>
+          <p:cNvSpPr>
+            <a:spLocks noGrp="1"/>
+          </p:cNvSpPr>
+          <p:nvPr>
+            <p:ph type="body" idx="3" sz="quarter"/>
+          </p:nvPr>
+        </p:nvSpPr>
+        <p:spPr/>
+        <p:txBody>
+          <a:bodyPr/>
+          <a:lstStyle/>
+          <a:p>
+            <a:r>
+              <a:t>Phases 1-4 are done - this is what you see today. Phase 5: ns-3 simulation for realistic network modeling. Phase 6: Upgrade to DQN and integrate with NASA's ION-DTN implementation. Phase 7: Hardware prototypes with SDRs and optical links. (1.5 minutes)</a:t>
+            </a:r>
+          </a:p>
+        </p:txBody>
+      </p:sp>
+      <p:sp>
+        <p:nvSpPr>
+          <p:cNvPr id="4" name="Slide Number Placeholder 3"/>
+          <p:cNvSpPr>
+            <a:spLocks noGrp="1"/>
+          </p:cNvSpPr>
+          <p:nvPr>
+            <p:ph type="sldNum" idx="5" sz="quarter"/>
+          </p:nvPr>
+        </p:nvSpPr>
+        <p:spPr/>
+      </p:sp>
+    </p:spTree>
+  </p:cSld>
+  <p:clrMapOvr>
+    <a:masterClrMapping/>
+  </p:clrMapOvr>
+</p:notes>
+</file>
+
+<file path=ppt/notesSlides/notesSlide26.xml><?xml version="1.0" encoding="utf-8"?>
+<p:notes xmlns:a="http://schemas.openxmlformats.org/drawingml/2006/main" xmlns:p="http://schemas.openxmlformats.org/presentationml/2006/main" xmlns:r="http://schemas.openxmlformats.org/officeDocument/2006/relationships">
+  <p:cSld>
+    <p:spTree>
+      <p:nvGrpSpPr>
+        <p:cNvPr id="1" name=""/>
+        <p:cNvGrpSpPr/>
+        <p:nvPr/>
+      </p:nvGrpSpPr>
+      <p:grpSpPr>
+        <a:xfrm>
+          <a:off x="0" y="0"/>
+          <a:ext cx="0" cy="0"/>
+          <a:chOff x="0" y="0"/>
+          <a:chExt cx="0" cy="0"/>
+        </a:xfrm>
+      </p:grpSpPr>
+      <p:sp>
+        <p:nvSpPr>
+          <p:cNvPr id="2" name="Slide Image Placeholder 1"/>
+          <p:cNvSpPr>
+            <a:spLocks noGrp="1"/>
+          </p:cNvSpPr>
+          <p:nvPr>
+            <p:ph type="sldImg" idx="2"/>
+          </p:nvPr>
+        </p:nvSpPr>
+        <p:spPr/>
+      </p:sp>
+      <p:sp>
+        <p:nvSpPr>
+          <p:cNvPr id="3" name="Notes Placeholder 2"/>
+          <p:cNvSpPr>
+            <a:spLocks noGrp="1"/>
+          </p:cNvSpPr>
+          <p:nvPr>
+            <p:ph type="body" idx="3" sz="quarter"/>
+          </p:nvPr>
+        </p:nvSpPr>
+        <p:spPr/>
+        <p:txBody>
+          <a:bodyPr/>
+          <a:lstStyle/>
+          <a:p>
+            <a:r>
+              <a:t>Summarize the problem and solution clearly. Re-read the exam topic verbatim. Point to the numbers. Offer to show live demos or answer questions. Thank the examiners. (1 minute)</a:t>
+            </a:r>
+          </a:p>
+        </p:txBody>
+      </p:sp>
+      <p:sp>
+        <p:nvSpPr>
+          <p:cNvPr id="4" name="Slide Number Placeholder 3"/>
+          <p:cNvSpPr>
+            <a:spLocks noGrp="1"/>
+          </p:cNvSpPr>
+          <p:nvPr>
+            <p:ph type="sldNum" idx="5" sz="quarter"/>
+          </p:nvPr>
+        </p:nvSpPr>
+        <p:spPr/>
+      </p:sp>
+    </p:spTree>
+  </p:cSld>
+  <p:clrMapOvr>
+    <a:masterClrMapping/>
+  </p:clrMapOvr>
+</p:notes>
+</file>
+
+<file path=ppt/notesSlides/notesSlide27.xml><?xml version="1.0" encoding="utf-8"?>
+<p:notes xmlns:a="http://schemas.openxmlformats.org/drawingml/2006/main" xmlns:p="http://schemas.openxmlformats.org/presentationml/2006/main" xmlns:r="http://schemas.openxmlformats.org/officeDocument/2006/relationships">
+  <p:cSld>
+    <p:spTree>
+      <p:nvGrpSpPr>
+        <p:cNvPr id="1" name=""/>
+        <p:cNvGrpSpPr/>
+        <p:nvPr/>
+      </p:nvGrpSpPr>
+      <p:grpSpPr>
+        <a:xfrm>
+          <a:off x="0" y="0"/>
+          <a:ext cx="0" cy="0"/>
+          <a:chOff x="0" y="0"/>
+          <a:chExt cx="0" cy="0"/>
+        </a:xfrm>
+      </p:grpSpPr>
+      <p:sp>
+        <p:nvSpPr>
+          <p:cNvPr id="2" name="Slide Image Placeholder 1"/>
+          <p:cNvSpPr>
+            <a:spLocks noGrp="1"/>
+          </p:cNvSpPr>
+          <p:nvPr>
+            <p:ph type="sldImg" idx="2"/>
+          </p:nvPr>
+        </p:nvSpPr>
+        <p:spPr/>
+      </p:sp>
+      <p:sp>
+        <p:nvSpPr>
+          <p:cNvPr id="3" name="Notes Placeholder 2"/>
+          <p:cNvSpPr>
+            <a:spLocks noGrp="1"/>
+          </p:cNvSpPr>
+          <p:nvPr>
+            <p:ph type="body" idx="3" sz="quarter"/>
+          </p:nvPr>
+        </p:nvSpPr>
+        <p:spPr/>
+        <p:txBody>
+          <a:bodyPr/>
+          <a:lstStyle/>
+          <a:p>
+            <a:r>
+              <a:t>Summarize the four key numbers: 10-100x faster, &gt;95% availability, AI-powered routing, quantum-secure. Invite questions confidently. Make eye contact. Point to the live demo link. Thank the audience. (30 seconds)</a:t>
+            </a:r>
+          </a:p>
+        </p:txBody>
+      </p:sp>
+      <p:sp>
+        <p:nvSpPr>
+          <p:cNvPr id="4" name="Slide Number Placeholder 3"/>
+          <p:cNvSpPr>
+            <a:spLocks noGrp="1"/>
+          </p:cNvSpPr>
+          <p:nvPr>
+            <p:ph type="sldNum" idx="5" sz="quarter"/>
+          </p:nvPr>
+        </p:nvSpPr>
+        <p:spPr/>
+      </p:sp>
+    </p:spTree>
+  </p:cSld>
+  <p:clrMapOvr>
+    <a:masterClrMapping/>
+  </p:clrMapOvr>
+</p:notes>
+</file>
+
+<file path=ppt/notesSlides/notesSlide3.xml><?xml version="1.0" encoding="utf-8"?>
+<p:notes xmlns:a="http://schemas.openxmlformats.org/drawingml/2006/main" xmlns:p="http://schemas.openxmlformats.org/presentationml/2006/main" xmlns:r="http://schemas.openxmlformats.org/officeDocument/2006/relationships">
+  <p:cSld>
+    <p:spTree>
+      <p:nvGrpSpPr>
+        <p:cNvPr id="1" name=""/>
+        <p:cNvGrpSpPr/>
+        <p:nvPr/>
+      </p:nvGrpSpPr>
+      <p:grpSpPr>
+        <a:xfrm>
+          <a:off x="0" y="0"/>
+          <a:ext cx="0" cy="0"/>
+          <a:chOff x="0" y="0"/>
+          <a:chExt cx="0" cy="0"/>
+        </a:xfrm>
+      </p:grpSpPr>
+      <p:sp>
+        <p:nvSpPr>
+          <p:cNvPr id="2" name="Slide Image Placeholder 1"/>
+          <p:cNvSpPr>
+            <a:spLocks noGrp="1"/>
+          </p:cNvSpPr>
+          <p:nvPr>
+            <p:ph type="sldImg" idx="2"/>
+          </p:nvPr>
+        </p:nvSpPr>
+        <p:spPr/>
+      </p:sp>
+      <p:sp>
+        <p:nvSpPr>
+          <p:cNvPr id="3" name="Notes Placeholder 2"/>
+          <p:cNvSpPr>
+            <a:spLocks noGrp="1"/>
+          </p:cNvSpPr>
+          <p:nvPr>
+            <p:ph type="body" idx="3" sz="quarter"/>
+          </p:nvPr>
+        </p:nvSpPr>
+        <p:spPr/>
+        <p:txBody>
+          <a:bodyPr/>
+          <a:lstStyle/>
+          <a:p>
+            <a:r>
+              <a:t>This slide sets up the narrative arc. First explain what AETHERIX is in plain language - it's like the postal service for interplanetary space. Then pivot to the problem: TCP/IP was never designed for space. 22-minute delays break every assumption. Solar conjunction blackouts. Static routing. Vulnerable crypto. Each problem maps to one of our solutions. (1.5 minutes)</a:t>
+            </a:r>
+          </a:p>
+        </p:txBody>
+      </p:sp>
+      <p:sp>
+        <p:nvSpPr>
+          <p:cNvPr id="4" name="Slide Number Placeholder 3"/>
+          <p:cNvSpPr>
+            <a:spLocks noGrp="1"/>
+          </p:cNvSpPr>
+          <p:nvPr>
+            <p:ph type="sldNum" idx="5" sz="quarter"/>
+          </p:nvPr>
+        </p:nvSpPr>
+        <p:spPr/>
+      </p:sp>
+    </p:spTree>
+  </p:cSld>
+  <p:clrMapOvr>
+    <a:masterClrMapping/>
+  </p:clrMapOvr>
+</p:notes>
+</file>
+
+<file path=ppt/notesSlides/notesSlide4.xml><?xml version="1.0" encoding="utf-8"?>
+<p:notes xmlns:a="http://schemas.openxmlformats.org/drawingml/2006/main" xmlns:p="http://schemas.openxmlformats.org/presentationml/2006/main" xmlns:r="http://schemas.openxmlformats.org/officeDocument/2006/relationships">
+  <p:cSld>
+    <p:spTree>
+      <p:nvGrpSpPr>
+        <p:cNvPr id="1" name=""/>
+        <p:cNvGrpSpPr/>
+        <p:nvPr/>
+      </p:nvGrpSpPr>
+      <p:grpSpPr>
+        <a:xfrm>
+          <a:off x="0" y="0"/>
+          <a:ext cx="0" cy="0"/>
+          <a:chOff x="0" y="0"/>
+          <a:chExt cx="0" cy="0"/>
+        </a:xfrm>
+      </p:grpSpPr>
+      <p:sp>
+        <p:nvSpPr>
+          <p:cNvPr id="2" name="Slide Image Placeholder 1"/>
+          <p:cNvSpPr>
+            <a:spLocks noGrp="1"/>
+          </p:cNvSpPr>
+          <p:nvPr>
+            <p:ph type="sldImg" idx="2"/>
+          </p:nvPr>
+        </p:nvSpPr>
+        <p:spPr/>
+      </p:sp>
+      <p:sp>
+        <p:nvSpPr>
+          <p:cNvPr id="3" name="Notes Placeholder 2"/>
+          <p:cNvSpPr>
+            <a:spLocks noGrp="1"/>
+          </p:cNvSpPr>
+          <p:nvPr>
+            <p:ph type="body" idx="3" sz="quarter"/>
+          </p:nvPr>
+        </p:nvSpPr>
+        <p:spPr/>
+        <p:txBody>
+          <a:bodyPr/>
+          <a:lstStyle/>
+          <a:p>
+            <a:r>
+              <a:t>Start with the scale. 54.6M to 401M km. Light itself takes 3-22 minutes one way. TCP/IP was designed for sub-second round trips. In space, by the time a packet acknowledgment returns, the link may be gone. Solar conjunction causes 2-week blackout. This is why NASA calls it Delay-Tolerant Networking. (1.5 minutes)</a:t>
+            </a:r>
+          </a:p>
+        </p:txBody>
+      </p:sp>
+      <p:sp>
+        <p:nvSpPr>
+          <p:cNvPr id="4" name="Slide Number Placeholder 3"/>
+          <p:cNvSpPr>
+            <a:spLocks noGrp="1"/>
+          </p:cNvSpPr>
+          <p:nvPr>
+            <p:ph type="sldNum" idx="5" sz="quarter"/>
+          </p:nvPr>
+        </p:nvSpPr>
+        <p:spPr/>
+      </p:sp>
+    </p:spTree>
+  </p:cSld>
+  <p:clrMapOvr>
+    <a:masterClrMapping/>
+  </p:clrMapOvr>
+</p:notes>
+</file>
+
+<file path=ppt/notesSlides/notesSlide5.xml><?xml version="1.0" encoding="utf-8"?>
+<p:notes xmlns:a="http://schemas.openxmlformats.org/drawingml/2006/main" xmlns:p="http://schemas.openxmlformats.org/presentationml/2006/main" xmlns:r="http://schemas.openxmlformats.org/officeDocument/2006/relationships">
+  <p:cSld>
+    <p:spTree>
+      <p:nvGrpSpPr>
+        <p:cNvPr id="1" name=""/>
+        <p:cNvGrpSpPr/>
+        <p:nvPr/>
+      </p:nvGrpSpPr>
+      <p:grpSpPr>
+        <a:xfrm>
+          <a:off x="0" y="0"/>
+          <a:ext cx="0" cy="0"/>
+          <a:chOff x="0" y="0"/>
+          <a:chExt cx="0" cy="0"/>
+        </a:xfrm>
+      </p:grpSpPr>
+      <p:sp>
+        <p:nvSpPr>
+          <p:cNvPr id="2" name="Slide Image Placeholder 1"/>
+          <p:cNvSpPr>
+            <a:spLocks noGrp="1"/>
+          </p:cNvSpPr>
+          <p:nvPr>
+            <p:ph type="sldImg" idx="2"/>
+          </p:nvPr>
+        </p:nvSpPr>
+        <p:spPr/>
+      </p:sp>
+      <p:sp>
+        <p:nvSpPr>
+          <p:cNvPr id="3" name="Notes Placeholder 2"/>
+          <p:cNvSpPr>
+            <a:spLocks noGrp="1"/>
+          </p:cNvSpPr>
+          <p:nvPr>
+            <p:ph type="body" idx="3" sz="quarter"/>
+          </p:nvPr>
+        </p:nvSpPr>
+        <p:spPr/>
+        <p:txBody>
+          <a:bodyPr/>
+          <a:lstStyle/>
+          <a:p>
+            <a:r>
+              <a:t>The key insight: instead of requiring an end-to-end connection like TCP, DTN works like the postal service. Each node takes custody of your data and forwards it when a link becomes available. Three pillars: BPv7 for the protocol, RL for intelligent routing, QKD for security. (1.5 minutes)</a:t>
+            </a:r>
+          </a:p>
+        </p:txBody>
+      </p:sp>
+      <p:sp>
+        <p:nvSpPr>
+          <p:cNvPr id="4" name="Slide Number Placeholder 3"/>
+          <p:cNvSpPr>
+            <a:spLocks noGrp="1"/>
+          </p:cNvSpPr>
+          <p:nvPr>
+            <p:ph type="sldNum" idx="5" sz="quarter"/>
+          </p:nvPr>
+        </p:nvSpPr>
+        <p:spPr/>
+      </p:sp>
+    </p:spTree>
+  </p:cSld>
+  <p:clrMapOvr>
+    <a:masterClrMapping/>
+  </p:clrMapOvr>
+</p:notes>
+</file>
+
+<file path=ppt/notesSlides/notesSlide6.xml><?xml version="1.0" encoding="utf-8"?>
+<p:notes xmlns:a="http://schemas.openxmlformats.org/drawingml/2006/main" xmlns:p="http://schemas.openxmlformats.org/presentationml/2006/main" xmlns:r="http://schemas.openxmlformats.org/officeDocument/2006/relationships">
+  <p:cSld>
+    <p:spTree>
+      <p:nvGrpSpPr>
+        <p:cNvPr id="1" name=""/>
+        <p:cNvGrpSpPr/>
+        <p:nvPr/>
+      </p:nvGrpSpPr>
+      <p:grpSpPr>
+        <a:xfrm>
+          <a:off x="0" y="0"/>
+          <a:ext cx="0" cy="0"/>
+          <a:chOff x="0" y="0"/>
+          <a:chExt cx="0" cy="0"/>
+        </a:xfrm>
+      </p:grpSpPr>
+      <p:sp>
+        <p:nvSpPr>
+          <p:cNvPr id="2" name="Slide Image Placeholder 1"/>
+          <p:cNvSpPr>
+            <a:spLocks noGrp="1"/>
+          </p:cNvSpPr>
+          <p:nvPr>
+            <p:ph type="sldImg" idx="2"/>
+          </p:nvPr>
+        </p:nvSpPr>
+        <p:spPr/>
+      </p:sp>
+      <p:sp>
+        <p:nvSpPr>
+          <p:cNvPr id="3" name="Notes Placeholder 2"/>
+          <p:cNvSpPr>
+            <a:spLocks noGrp="1"/>
+          </p:cNvSpPr>
+          <p:nvPr>
+            <p:ph type="body" idx="3" sz="quarter"/>
+          </p:nvPr>
+        </p:nvSpPr>
+        <p:spPr/>
+        <p:txBody>
+          <a:bodyPr/>
+          <a:lstStyle/>
+          <a:p>
+            <a:r>
+              <a:t>Show the architecture. Six core modules feed into the simulation engine, which feeds the web showcase. Standards compliance at the bottom. Point to each module as you explain. (1 minute)</a:t>
+            </a:r>
+          </a:p>
+        </p:txBody>
+      </p:sp>
+      <p:sp>
+        <p:nvSpPr>
+          <p:cNvPr id="4" name="Slide Number Placeholder 3"/>
+          <p:cNvSpPr>
+            <a:spLocks noGrp="1"/>
+          </p:cNvSpPr>
+          <p:nvPr>
+            <p:ph type="sldNum" idx="5" sz="quarter"/>
+          </p:nvPr>
+        </p:nvSpPr>
+        <p:spPr/>
+      </p:sp>
+    </p:spTree>
+  </p:cSld>
+  <p:clrMapOvr>
+    <a:masterClrMapping/>
+  </p:clrMapOvr>
+</p:notes>
+</file>
+
+<file path=ppt/notesSlides/notesSlide7.xml><?xml version="1.0" encoding="utf-8"?>
+<p:notes xmlns:a="http://schemas.openxmlformats.org/drawingml/2006/main" xmlns:p="http://schemas.openxmlformats.org/presentationml/2006/main" xmlns:r="http://schemas.openxmlformats.org/officeDocument/2006/relationships">
+  <p:cSld>
+    <p:spTree>
+      <p:nvGrpSpPr>
+        <p:cNvPr id="1" name=""/>
+        <p:cNvGrpSpPr/>
+        <p:nvPr/>
+      </p:nvGrpSpPr>
+      <p:grpSpPr>
+        <a:xfrm>
+          <a:off x="0" y="0"/>
+          <a:ext cx="0" cy="0"/>
+          <a:chOff x="0" y="0"/>
+          <a:chExt cx="0" cy="0"/>
+        </a:xfrm>
+      </p:grpSpPr>
+      <p:sp>
+        <p:nvSpPr>
+          <p:cNvPr id="2" name="Slide Image Placeholder 1"/>
+          <p:cNvSpPr>
+            <a:spLocks noGrp="1"/>
+          </p:cNvSpPr>
+          <p:nvPr>
+            <p:ph type="sldImg" idx="2"/>
+          </p:nvPr>
+        </p:nvSpPr>
+        <p:spPr/>
+      </p:sp>
+      <p:sp>
+        <p:nvSpPr>
+          <p:cNvPr id="3" name="Notes Placeholder 2"/>
+          <p:cNvSpPr>
+            <a:spLocks noGrp="1"/>
+          </p:cNvSpPr>
+          <p:nvPr>
+            <p:ph type="body" idx="3" sz="quarter"/>
+          </p:nvPr>
+        </p:nvSpPr>
+        <p:spPr/>
+        <p:txBody>
+          <a:bodyPr/>
+          <a:lstStyle/>
+          <a:p>
+            <a:r>
+              <a:t>Architecture diagram showing source modules feeding simulation engine and web demos.</a:t>
+            </a:r>
+          </a:p>
+        </p:txBody>
+      </p:sp>
+      <p:sp>
+        <p:nvSpPr>
+          <p:cNvPr id="4" name="Slide Number Placeholder 3"/>
+          <p:cNvSpPr>
+            <a:spLocks noGrp="1"/>
+          </p:cNvSpPr>
+          <p:nvPr>
+            <p:ph type="sldNum" idx="5" sz="quarter"/>
+          </p:nvPr>
+        </p:nvSpPr>
+        <p:spPr/>
+      </p:sp>
+    </p:spTree>
+  </p:cSld>
+  <p:clrMapOvr>
+    <a:masterClrMapping/>
+  </p:clrMapOvr>
+</p:notes>
+</file>
+
+<file path=ppt/notesSlides/notesSlide8.xml><?xml version="1.0" encoding="utf-8"?>
+<p:notes xmlns:a="http://schemas.openxmlformats.org/drawingml/2006/main" xmlns:p="http://schemas.openxmlformats.org/presentationml/2006/main" xmlns:r="http://schemas.openxmlformats.org/officeDocument/2006/relationships">
+  <p:cSld>
+    <p:spTree>
+      <p:nvGrpSpPr>
+        <p:cNvPr id="1" name=""/>
+        <p:cNvGrpSpPr/>
+        <p:nvPr/>
+      </p:nvGrpSpPr>
+      <p:grpSpPr>
+        <a:xfrm>
+          <a:off x="0" y="0"/>
+          <a:ext cx="0" cy="0"/>
+          <a:chOff x="0" y="0"/>
+          <a:chExt cx="0" cy="0"/>
+        </a:xfrm>
+      </p:grpSpPr>
+      <p:sp>
+        <p:nvSpPr>
+          <p:cNvPr id="2" name="Slide Image Placeholder 1"/>
+          <p:cNvSpPr>
+            <a:spLocks noGrp="1"/>
+          </p:cNvSpPr>
+          <p:nvPr>
+            <p:ph type="sldImg" idx="2"/>
+          </p:nvPr>
+        </p:nvSpPr>
+        <p:spPr/>
+      </p:sp>
+      <p:sp>
+        <p:nvSpPr>
+          <p:cNvPr id="3" name="Notes Placeholder 2"/>
+          <p:cNvSpPr>
+            <a:spLocks noGrp="1"/>
+          </p:cNvSpPr>
+          <p:nvPr>
+            <p:ph type="body" idx="3" sz="quarter"/>
+          </p:nvPr>
+        </p:nvSpPr>
+        <p:spPr/>
+        <p:txBody>
+          <a:bodyPr/>
+          <a:lstStyle/>
+          <a:p>
+            <a:r>
+              <a:t>BPv7 is the postal service protocol. Walk through the stack: Application at top, BPv7 as the store-and-forward layer, three convergence layers for different link types, physical at bottom. Custody transfer is the key innovation - each node takes legal responsibility. Priority P0 (emergency) to P4 (bulk). (2 minutes)</a:t>
+            </a:r>
+          </a:p>
+        </p:txBody>
+      </p:sp>
+      <p:sp>
+        <p:nvSpPr>
+          <p:cNvPr id="4" name="Slide Number Placeholder 3"/>
+          <p:cNvSpPr>
+            <a:spLocks noGrp="1"/>
+          </p:cNvSpPr>
+          <p:nvPr>
+            <p:ph type="sldNum" idx="5" sz="quarter"/>
+          </p:nvPr>
+        </p:nvSpPr>
+        <p:spPr/>
+      </p:sp>
+    </p:spTree>
+  </p:cSld>
+  <p:clrMapOvr>
+    <a:masterClrMapping/>
+  </p:clrMapOvr>
+</p:notes>
+</file>
+
+<file path=ppt/notesSlides/notesSlide9.xml><?xml version="1.0" encoding="utf-8"?>
+<p:notes xmlns:a="http://schemas.openxmlformats.org/drawingml/2006/main" xmlns:p="http://schemas.openxmlformats.org/presentationml/2006/main" xmlns:r="http://schemas.openxmlformats.org/officeDocument/2006/relationships">
+  <p:cSld>
+    <p:spTree>
+      <p:nvGrpSpPr>
+        <p:cNvPr id="1" name=""/>
+        <p:cNvGrpSpPr/>
+        <p:nvPr/>
+      </p:nvGrpSpPr>
+      <p:grpSpPr>
+        <a:xfrm>
+          <a:off x="0" y="0"/>
+          <a:ext cx="0" cy="0"/>
+          <a:chOff x="0" y="0"/>
+          <a:chExt cx="0" cy="0"/>
+        </a:xfrm>
+      </p:grpSpPr>
+      <p:sp>
+        <p:nvSpPr>
+          <p:cNvPr id="2" name="Slide Image Placeholder 1"/>
+          <p:cNvSpPr>
+            <a:spLocks noGrp="1"/>
+          </p:cNvSpPr>
+          <p:nvPr>
+            <p:ph type="sldImg" idx="2"/>
+          </p:nvPr>
+        </p:nvSpPr>
+        <p:spPr/>
+      </p:sp>
+      <p:sp>
+        <p:nvSpPr>
+          <p:cNvPr id="3" name="Notes Placeholder 2"/>
+          <p:cNvSpPr>
+            <a:spLocks noGrp="1"/>
+          </p:cNvSpPr>
+          <p:nvPr>
+            <p:ph type="body" idx="3" sz="quarter"/>
+          </p:nvPr>
+        </p:nvSpPr>
+        <p:spPr/>
+        <p:txBody>
+          <a:bodyPr/>
+          <a:lstStyle/>
+          <a:p>
+            <a:r>
+              <a:t>Walk through the store-and-forward process. Bundle arrives, gets stored, node waits for next contact opportunity, then forwards. If link drops, bundle stays stored and retries. No data loss. This is fundamentally different from TCP's end-to-end retransmission. (1.5 minutes)</a:t>
+            </a:r>
+          </a:p>
+        </p:txBody>
+      </p:sp>
+      <p:sp>
+        <p:nvSpPr>
+          <p:cNvPr id="4" name="Slide Number Placeholder 3"/>
+          <p:cNvSpPr>
+            <a:spLocks noGrp="1"/>
+          </p:cNvSpPr>
+          <p:nvPr>
+            <p:ph type="sldNum" idx="5" sz="quarter"/>
+          </p:nvPr>
+        </p:nvSpPr>
+        <p:spPr/>
+      </p:sp>
+    </p:spTree>
+  </p:cSld>
+  <p:clrMapOvr>
+    <a:masterClrMapping/>
+  </p:clrMapOvr>
+</p:notes>
 </file>
 
 <file path=ppt/slideLayouts/slideLayout1.xml><?xml version="1.0" encoding="utf-8"?>
@@ -30049,4 +32289,324 @@
   </a:objectDefaults>
   <a:extraClrSchemeLst/>
 </a:theme>
+</file>
+
+<file path=ppt/theme/theme2.xml><?xml version="1.0" encoding="utf-8"?>
+<a:theme xmlns:a="http://schemas.openxmlformats.org/drawingml/2006/main" name="Office Theme">
+  <a:themeElements>
+    <a:clrScheme name="Office">
+      <a:dk1>
+        <a:sysClr val="windowText" lastClr="000000"/>
+      </a:dk1>
+      <a:lt1>
+        <a:sysClr val="window" lastClr="FFFFFF"/>
+      </a:lt1>
+      <a:dk2>
+        <a:srgbClr val="1F497D"/>
+      </a:dk2>
+      <a:lt2>
+        <a:srgbClr val="EEECE1"/>
+      </a:lt2>
+      <a:accent1>
+        <a:srgbClr val="4F81BD"/>
+      </a:accent1>
+      <a:accent2>
+        <a:srgbClr val="C0504D"/>
+      </a:accent2>
+      <a:accent3>
+        <a:srgbClr val="9BBB59"/>
+      </a:accent3>
+      <a:accent4>
+        <a:srgbClr val="8064A2"/>
+      </a:accent4>
+      <a:accent5>
+        <a:srgbClr val="4BACC6"/>
+      </a:accent5>
+      <a:accent6>
+        <a:srgbClr val="F79646"/>
+      </a:accent6>
+      <a:hlink>
+        <a:srgbClr val="0000FF"/>
+      </a:hlink>
+      <a:folHlink>
+        <a:srgbClr val="800080"/>
+      </a:folHlink>
+    </a:clrScheme>
+    <a:fontScheme name="Office">
+      <a:majorFont>
+        <a:latin typeface="Calibri"/>
+        <a:ea typeface=""/>
+        <a:cs typeface=""/>
+        <a:font script="Jpan" typeface="ＭＳ Ｐゴシック"/>
+        <a:font script="Hang" typeface="맑은 고딕"/>
+        <a:font script="Hans" typeface="宋体"/>
+        <a:font script="Hant" typeface="新細明體"/>
+        <a:font script="Arab" typeface="Times New Roman"/>
+        <a:font script="Hebr" typeface="Times New Roman"/>
+        <a:font script="Thai" typeface="Angsana New"/>
+        <a:font script="Ethi" typeface="Nyala"/>
+        <a:font script="Beng" typeface="Vrinda"/>
+        <a:font script="Gujr" typeface="Shruti"/>
+        <a:font script="Khmr" typeface="MoolBoran"/>
+        <a:font script="Knda" typeface="Tunga"/>
+        <a:font script="Guru" typeface="Raavi"/>
+        <a:font script="Cans" typeface="Euphemia"/>
+        <a:font script="Cher" typeface="Plantagenet Cherokee"/>
+        <a:font script="Yiii" typeface="Microsoft Yi Baiti"/>
+        <a:font script="Tibt" typeface="Microsoft Himalaya"/>
+        <a:font script="Thaa" typeface="MV Boli"/>
+        <a:font script="Deva" typeface="Mangal"/>
+        <a:font script="Telu" typeface="Gautami"/>
+        <a:font script="Taml" typeface="Latha"/>
+        <a:font script="Syrc" typeface="Estrangelo Edessa"/>
+        <a:font script="Orya" typeface="Kalinga"/>
+        <a:font script="Mlym" typeface="Kartika"/>
+        <a:font script="Laoo" typeface="DokChampa"/>
+        <a:font script="Sinh" typeface="Iskoola Pota"/>
+        <a:font script="Mong" typeface="Mongolian Baiti"/>
+        <a:font script="Viet" typeface="Times New Roman"/>
+        <a:font script="Uigh" typeface="Microsoft Uighur"/>
+        <a:font script="Geor" typeface="Sylfaen"/>
+      </a:majorFont>
+      <a:minorFont>
+        <a:latin typeface="Calibri"/>
+        <a:ea typeface=""/>
+        <a:cs typeface=""/>
+        <a:font script="Jpan" typeface="ＭＳ Ｐゴシック"/>
+        <a:font script="Hang" typeface="맑은 고딕"/>
+        <a:font script="Hans" typeface="宋体"/>
+        <a:font script="Hant" typeface="新細明體"/>
+        <a:font script="Arab" typeface="Arial"/>
+        <a:font script="Hebr" typeface="Arial"/>
+        <a:font script="Thai" typeface="Cordia New"/>
+        <a:font script="Ethi" typeface="Nyala"/>
+        <a:font script="Beng" typeface="Vrinda"/>
+        <a:font script="Gujr" typeface="Shruti"/>
+        <a:font script="Khmr" typeface="DaunPenh"/>
+        <a:font script="Knda" typeface="Tunga"/>
+        <a:font script="Guru" typeface="Raavi"/>
+        <a:font script="Cans" typeface="Euphemia"/>
+        <a:font script="Cher" typeface="Plantagenet Cherokee"/>
+        <a:font script="Yiii" typeface="Microsoft Yi Baiti"/>
+        <a:font script="Tibt" typeface="Microsoft Himalaya"/>
+        <a:font script="Thaa" typeface="MV Boli"/>
+        <a:font script="Deva" typeface="Mangal"/>
+        <a:font script="Telu" typeface="Gautami"/>
+        <a:font script="Taml" typeface="Latha"/>
+        <a:font script="Syrc" typeface="Estrangelo Edessa"/>
+        <a:font script="Orya" typeface="Kalinga"/>
+        <a:font script="Mlym" typeface="Kartika"/>
+        <a:font script="Laoo" typeface="DokChampa"/>
+        <a:font script="Sinh" typeface="Iskoola Pota"/>
+        <a:font script="Mong" typeface="Mongolian Baiti"/>
+        <a:font script="Viet" typeface="Arial"/>
+        <a:font script="Uigh" typeface="Microsoft Uighur"/>
+        <a:font script="Geor" typeface="Sylfaen"/>
+      </a:minorFont>
+    </a:fontScheme>
+    <a:fmtScheme name="Office">
+      <a:fillStyleLst>
+        <a:solidFill>
+          <a:schemeClr val="phClr"/>
+        </a:solidFill>
+        <a:gradFill rotWithShape="1">
+          <a:gsLst>
+            <a:gs pos="0">
+              <a:schemeClr val="phClr">
+                <a:tint val="50000"/>
+                <a:satMod val="300000"/>
+              </a:schemeClr>
+            </a:gs>
+            <a:gs pos="35000">
+              <a:schemeClr val="phClr">
+                <a:tint val="37000"/>
+                <a:satMod val="300000"/>
+              </a:schemeClr>
+            </a:gs>
+            <a:gs pos="100000">
+              <a:schemeClr val="phClr">
+                <a:tint val="15000"/>
+                <a:satMod val="350000"/>
+              </a:schemeClr>
+            </a:gs>
+          </a:gsLst>
+          <a:lin ang="16200000" scaled="1"/>
+        </a:gradFill>
+        <a:gradFill rotWithShape="1">
+          <a:gsLst>
+            <a:gs pos="0">
+              <a:schemeClr val="phClr">
+                <a:tint val="100000"/>
+                <a:shade val="100000"/>
+                <a:satMod val="130000"/>
+              </a:schemeClr>
+            </a:gs>
+            <a:gs pos="100000">
+              <a:schemeClr val="phClr">
+                <a:tint val="50000"/>
+                <a:shade val="100000"/>
+                <a:satMod val="350000"/>
+              </a:schemeClr>
+            </a:gs>
+          </a:gsLst>
+          <a:lin ang="16200000" scaled="0"/>
+        </a:gradFill>
+      </a:fillStyleLst>
+      <a:lnStyleLst>
+        <a:ln w="9525" cap="flat" cmpd="sng" algn="ctr">
+          <a:solidFill>
+            <a:schemeClr val="phClr">
+              <a:shade val="95000"/>
+              <a:satMod val="105000"/>
+            </a:schemeClr>
+          </a:solidFill>
+          <a:prstDash val="solid"/>
+        </a:ln>
+        <a:ln w="25400" cap="flat" cmpd="sng" algn="ctr">
+          <a:solidFill>
+            <a:schemeClr val="phClr"/>
+          </a:solidFill>
+          <a:prstDash val="solid"/>
+        </a:ln>
+        <a:ln w="38100" cap="flat" cmpd="sng" algn="ctr">
+          <a:solidFill>
+            <a:schemeClr val="phClr"/>
+          </a:solidFill>
+          <a:prstDash val="solid"/>
+        </a:ln>
+      </a:lnStyleLst>
+      <a:effectStyleLst>
+        <a:effectStyle>
+          <a:effectLst>
+            <a:outerShdw blurRad="40000" dist="20000" dir="5400000" rotWithShape="0">
+              <a:srgbClr val="000000">
+                <a:alpha val="38000"/>
+              </a:srgbClr>
+            </a:outerShdw>
+          </a:effectLst>
+        </a:effectStyle>
+        <a:effectStyle>
+          <a:effectLst>
+            <a:outerShdw blurRad="40000" dist="23000" dir="5400000" rotWithShape="0">
+              <a:srgbClr val="000000">
+                <a:alpha val="35000"/>
+              </a:srgbClr>
+            </a:outerShdw>
+          </a:effectLst>
+        </a:effectStyle>
+        <a:effectStyle>
+          <a:effectLst>
+            <a:outerShdw blurRad="40000" dist="23000" dir="5400000" rotWithShape="0">
+              <a:srgbClr val="000000">
+                <a:alpha val="35000"/>
+              </a:srgbClr>
+            </a:outerShdw>
+          </a:effectLst>
+          <a:scene3d>
+            <a:camera prst="orthographicFront">
+              <a:rot lat="0" lon="0" rev="0"/>
+            </a:camera>
+            <a:lightRig rig="threePt" dir="t">
+              <a:rot lat="0" lon="0" rev="1200000"/>
+            </a:lightRig>
+          </a:scene3d>
+          <a:sp3d>
+            <a:bevelT w="63500" h="25400"/>
+          </a:sp3d>
+        </a:effectStyle>
+      </a:effectStyleLst>
+      <a:bgFillStyleLst>
+        <a:solidFill>
+          <a:schemeClr val="phClr"/>
+        </a:solidFill>
+        <a:gradFill rotWithShape="1">
+          <a:gsLst>
+            <a:gs pos="0">
+              <a:schemeClr val="phClr">
+                <a:tint val="40000"/>
+                <a:satMod val="350000"/>
+              </a:schemeClr>
+            </a:gs>
+            <a:gs pos="40000">
+              <a:schemeClr val="phClr">
+                <a:tint val="45000"/>
+                <a:shade val="99000"/>
+                <a:satMod val="350000"/>
+              </a:schemeClr>
+            </a:gs>
+            <a:gs pos="100000">
+              <a:schemeClr val="phClr">
+                <a:shade val="20000"/>
+                <a:satMod val="255000"/>
+              </a:schemeClr>
+            </a:gs>
+          </a:gsLst>
+          <a:path path="circle">
+            <a:fillToRect l="50000" t="-80000" r="50000" b="180000"/>
+          </a:path>
+        </a:gradFill>
+        <a:gradFill rotWithShape="1">
+          <a:gsLst>
+            <a:gs pos="0">
+              <a:schemeClr val="phClr">
+                <a:tint val="80000"/>
+                <a:satMod val="300000"/>
+              </a:schemeClr>
+            </a:gs>
+            <a:gs pos="100000">
+              <a:schemeClr val="phClr">
+                <a:shade val="30000"/>
+                <a:satMod val="200000"/>
+              </a:schemeClr>
+            </a:gs>
+          </a:gsLst>
+          <a:path path="circle">
+            <a:fillToRect l="50000" t="50000" r="50000" b="50000"/>
+          </a:path>
+        </a:gradFill>
+      </a:bgFillStyleLst>
+    </a:fmtScheme>
+  </a:themeElements>
+  <a:objectDefaults>
+    <a:spDef>
+      <a:spPr/>
+      <a:bodyPr/>
+      <a:lstStyle/>
+      <a:style>
+        <a:lnRef idx="1">
+          <a:schemeClr val="accent1"/>
+        </a:lnRef>
+        <a:fillRef idx="3">
+          <a:schemeClr val="accent1"/>
+        </a:fillRef>
+        <a:effectRef idx="2">
+          <a:schemeClr val="accent1"/>
+        </a:effectRef>
+        <a:fontRef idx="minor">
+          <a:schemeClr val="lt1"/>
+        </a:fontRef>
+      </a:style>
+    </a:spDef>
+    <a:lnDef>
+      <a:spPr/>
+      <a:bodyPr/>
+      <a:lstStyle/>
+      <a:style>
+        <a:lnRef idx="2">
+          <a:schemeClr val="accent1"/>
+        </a:lnRef>
+        <a:fillRef idx="0">
+          <a:schemeClr val="accent1"/>
+        </a:fillRef>
+        <a:effectRef idx="1">
+          <a:schemeClr val="accent1"/>
+        </a:effectRef>
+        <a:fontRef idx="minor">
+          <a:schemeClr val="tx1"/>
+        </a:fontRef>
+      </a:style>
+    </a:lnDef>
+  </a:objectDefaults>
+  <a:extraClrSchemeLst/>
+</a:theme>
 </file>
</xml_diff>